<commit_message>
Day 4 morning accessible: convert 23 embedded OLE equations to real text
The earlier pass only scanned <p:pic> shapes, so it missed every Microsoft Equation
Editor OLE object -- these render as pictures, carry no alt text and are unreadable to
a screen reader. Converts the 20 display equations to text, splices the 3 inline symbols
(p-hat, l-infinity) into their sentences so they no longer read as a gap, and replaces
16 legacy Symbol-font private-use characters with real Unicode Greek.

Co-Authored-By: Claude Opus 4.8 <noreply@anthropic.com>
</commit_message>
<xml_diff>
--- a/Day4_Likelihood_BayesI/FW536_Day4_Morning_maximum likelihod_accessible.pptx
+++ b/Day4_Likelihood_BayesI/FW536_Day4_Morning_maximum likelihod_accessible.pptx
@@ -7873,106 +7873,6 @@
           </a:p>
         </p:txBody>
       </p:sp>
-      <p:graphicFrame>
-        <p:nvGraphicFramePr>
-          <p:cNvPr id="324611" name="Object 4"/>
-          <p:cNvGraphicFramePr>
-            <a:graphicFrameLocks noGrp="1" noChangeAspect="1"/>
-          </p:cNvGraphicFramePr>
-          <p:nvPr>
-            <p:ph sz="half" idx="1"/>
-            <p:extLst>
-              <p:ext uri="{D42A27DB-BD31-4B8C-83A1-F6EECF244321}">
-                <p14:modId xmlns:p14="http://schemas.microsoft.com/office/powerpoint/2010/main" val="752975029"/>
-              </p:ext>
-            </p:extLst>
-          </p:nvPr>
-        </p:nvGraphicFramePr>
-        <p:xfrm>
-          <a:off x="3136076" y="3347258"/>
-          <a:ext cx="2987675" cy="571500"/>
-        </p:xfrm>
-        <a:graphic>
-          <a:graphicData uri="http://schemas.openxmlformats.org/presentationml/2006/ole">
-            <mc:AlternateContent xmlns:mc="http://schemas.openxmlformats.org/markup-compatibility/2006">
-              <mc:Choice xmlns:v="urn:schemas-microsoft-com:vml" Requires="v">
-                <p:oleObj name="Equation" r:id="rId3" imgW="1193800" imgH="228600" progId="Equation.DSMT4">
-                  <p:embed/>
-                </p:oleObj>
-              </mc:Choice>
-              <mc:Fallback>
-                <p:oleObj name="Equation" r:id="rId3" imgW="1193800" imgH="228600" progId="Equation.DSMT4">
-                  <p:embed/>
-                  <p:pic>
-                    <p:nvPicPr>
-                      <p:cNvPr id="0" name=""/>
-                      <p:cNvPicPr>
-                        <a:picLocks noChangeAspect="1" noChangeArrowheads="1"/>
-                      </p:cNvPicPr>
-                      <p:nvPr/>
-                    </p:nvPicPr>
-                    <p:blipFill>
-                      <a:blip r:embed="rId4">
-                        <a:extLst>
-                          <a:ext uri="{28A0092B-C50C-407E-A947-70E740481C1C}">
-                            <a14:useLocalDpi xmlns:a14="http://schemas.microsoft.com/office/drawing/2010/main" val="0"/>
-                          </a:ext>
-                        </a:extLst>
-                      </a:blip>
-                      <a:srcRect/>
-                      <a:stretch>
-                        <a:fillRect/>
-                      </a:stretch>
-                    </p:blipFill>
-                    <p:spPr bwMode="auto">
-                      <a:xfrm>
-                        <a:off x="3136076" y="3347258"/>
-                        <a:ext cx="2987675" cy="571500"/>
-                      </a:xfrm>
-                      <a:prstGeom prst="rect">
-                        <a:avLst/>
-                      </a:prstGeom>
-                      <a:noFill/>
-                      <a:ln>
-                        <a:noFill/>
-                      </a:ln>
-                      <a:effectLst/>
-                      <a:extLst>
-                        <a:ext uri="{909E8E84-426E-40DD-AFC4-6F175D3DCCD1}">
-                          <a14:hiddenFill xmlns:a14="http://schemas.microsoft.com/office/drawing/2010/main">
-                            <a:solidFill>
-                              <a:srgbClr val="FFFFFF"/>
-                            </a:solidFill>
-                          </a14:hiddenFill>
-                        </a:ext>
-                        <a:ext uri="{91240B29-F687-4F45-9708-019B960494DF}">
-                          <a14:hiddenLine xmlns:a14="http://schemas.microsoft.com/office/drawing/2010/main" w="9525">
-                            <a:solidFill>
-                              <a:srgbClr val="000000"/>
-                            </a:solidFill>
-                            <a:miter lim="800000"/>
-                            <a:headEnd/>
-                            <a:tailEnd/>
-                          </a14:hiddenLine>
-                        </a:ext>
-                        <a:ext uri="{AF507438-7753-43E0-B8FC-AC1667EBCBE1}">
-                          <a14:hiddenEffects xmlns:a14="http://schemas.microsoft.com/office/drawing/2010/main">
-                            <a:effectLst>
-                              <a:outerShdw dist="35921" dir="2700000" algn="ctr" rotWithShape="0">
-                                <a:srgbClr val="808080"/>
-                              </a:outerShdw>
-                            </a:effectLst>
-                          </a14:hiddenEffects>
-                        </a:ext>
-                      </a:extLst>
-                    </p:spPr>
-                  </p:pic>
-                </p:oleObj>
-              </mc:Fallback>
-            </mc:AlternateContent>
-          </a:graphicData>
-        </a:graphic>
-      </p:graphicFrame>
       <p:sp>
         <p:nvSpPr>
           <p:cNvPr id="19461" name="Rectangle 5"/>
@@ -8149,111 +8049,21 @@
             </a:r>
             <a:r>
               <a:rPr lang="en-AU" altLang="en-US" dirty="0"/>
-              <a:t> and denote it as     .</a:t>
+              <a:t> and denote it as </a:t>
+            </a:r>
+            <a:r>
+              <a:rPr lang="en-AU" altLang="en-US" dirty="0">
+                <a:latin typeface="Cambria"/>
+              </a:rPr>
+              <a:t>p̂</a:t>
+            </a:r>
+            <a:r>
+              <a:rPr lang="en-AU" altLang="en-US" dirty="0"/>
+              <a:t>.</a:t>
             </a:r>
           </a:p>
         </p:txBody>
       </p:sp>
-      <p:graphicFrame>
-        <p:nvGraphicFramePr>
-          <p:cNvPr id="324613" name="Object 6"/>
-          <p:cNvGraphicFramePr>
-            <a:graphicFrameLocks noGrp="1" noChangeAspect="1"/>
-          </p:cNvGraphicFramePr>
-          <p:nvPr>
-            <p:ph sz="half" idx="2"/>
-            <p:extLst>
-              <p:ext uri="{D42A27DB-BD31-4B8C-83A1-F6EECF244321}">
-                <p14:modId xmlns:p14="http://schemas.microsoft.com/office/powerpoint/2010/main" val="2683849734"/>
-              </p:ext>
-            </p:extLst>
-          </p:nvPr>
-        </p:nvGraphicFramePr>
-        <p:xfrm>
-          <a:off x="9726405" y="5164847"/>
-          <a:ext cx="381000" cy="508000"/>
-        </p:xfrm>
-        <a:graphic>
-          <a:graphicData uri="http://schemas.openxmlformats.org/presentationml/2006/ole">
-            <mc:AlternateContent xmlns:mc="http://schemas.openxmlformats.org/markup-compatibility/2006">
-              <mc:Choice xmlns:v="urn:schemas-microsoft-com:vml" Requires="v">
-                <p:oleObj name="Equation" r:id="rId5" imgW="152268" imgH="203024" progId="Equation.DSMT4">
-                  <p:embed/>
-                </p:oleObj>
-              </mc:Choice>
-              <mc:Fallback>
-                <p:oleObj name="Equation" r:id="rId5" imgW="152268" imgH="203024" progId="Equation.DSMT4">
-                  <p:embed/>
-                  <p:pic>
-                    <p:nvPicPr>
-                      <p:cNvPr id="0" name=""/>
-                      <p:cNvPicPr>
-                        <a:picLocks noChangeAspect="1" noChangeArrowheads="1"/>
-                      </p:cNvPicPr>
-                      <p:nvPr/>
-                    </p:nvPicPr>
-                    <p:blipFill>
-                      <a:blip r:embed="rId6">
-                        <a:extLst>
-                          <a:ext uri="{28A0092B-C50C-407E-A947-70E740481C1C}">
-                            <a14:useLocalDpi xmlns:a14="http://schemas.microsoft.com/office/drawing/2010/main" val="0"/>
-                          </a:ext>
-                        </a:extLst>
-                      </a:blip>
-                      <a:srcRect/>
-                      <a:stretch>
-                        <a:fillRect/>
-                      </a:stretch>
-                    </p:blipFill>
-                    <p:spPr bwMode="auto">
-                      <a:xfrm>
-                        <a:off x="9726405" y="5164847"/>
-                        <a:ext cx="381000" cy="508000"/>
-                      </a:xfrm>
-                      <a:prstGeom prst="rect">
-                        <a:avLst/>
-                      </a:prstGeom>
-                      <a:noFill/>
-                      <a:ln>
-                        <a:noFill/>
-                      </a:ln>
-                      <a:effectLst/>
-                      <a:extLst>
-                        <a:ext uri="{909E8E84-426E-40DD-AFC4-6F175D3DCCD1}">
-                          <a14:hiddenFill xmlns:a14="http://schemas.microsoft.com/office/drawing/2010/main">
-                            <a:solidFill>
-                              <a:srgbClr val="FFFFFF"/>
-                            </a:solidFill>
-                          </a14:hiddenFill>
-                        </a:ext>
-                        <a:ext uri="{91240B29-F687-4F45-9708-019B960494DF}">
-                          <a14:hiddenLine xmlns:a14="http://schemas.microsoft.com/office/drawing/2010/main" w="9525">
-                            <a:solidFill>
-                              <a:srgbClr val="000000"/>
-                            </a:solidFill>
-                            <a:miter lim="800000"/>
-                            <a:headEnd/>
-                            <a:tailEnd/>
-                          </a14:hiddenLine>
-                        </a:ext>
-                        <a:ext uri="{AF507438-7753-43E0-B8FC-AC1667EBCBE1}">
-                          <a14:hiddenEffects xmlns:a14="http://schemas.microsoft.com/office/drawing/2010/main">
-                            <a:effectLst>
-                              <a:outerShdw dist="35921" dir="2700000" algn="ctr" rotWithShape="0">
-                                <a:srgbClr val="808080"/>
-                              </a:outerShdw>
-                            </a:effectLst>
-                          </a14:hiddenEffects>
-                        </a:ext>
-                      </a:extLst>
-                    </p:spPr>
-                  </p:pic>
-                </p:oleObj>
-              </mc:Fallback>
-            </mc:AlternateContent>
-          </a:graphicData>
-        </a:graphic>
-      </p:graphicFrame>
       <p:sp>
         <p:nvSpPr>
           <p:cNvPr id="2" name="TextBox 1"/>
@@ -8279,6 +8089,55 @@
             <a:r>
               <a:rPr lang="en-US" dirty="0"/>
               <a:t>Is something missing? Why is this ok?</a:t>
+            </a:r>
+          </a:p>
+        </p:txBody>
+      </p:sp>
+      <p:sp>
+        <p:nvSpPr>
+          <p:cNvPr id="324614" name="TextBox 324613"/>
+          <p:cNvSpPr txBox="1"/>
+          <p:nvPr/>
+        </p:nvSpPr>
+        <p:spPr>
+          <a:xfrm>
+            <a:off x="3136076" y="3347258"/>
+            <a:ext cx="2987675" cy="571500"/>
+          </a:xfrm>
+          <a:prstGeom prst="rect">
+            <a:avLst/>
+          </a:prstGeom>
+          <a:noFill/>
+        </p:spPr>
+        <p:txBody>
+          <a:bodyPr wrap="square" anchor="ctr" lIns="0" rIns="0" tIns="0" bIns="0">
+            <a:spAutoFit/>
+          </a:bodyPr>
+          <a:lstStyle/>
+          <a:p>
+            <a:r>
+              <a:rPr sz="2100">
+                <a:latin typeface="Cambria"/>
+              </a:rPr>
+              <a:t>L(p) = p</a:t>
+            </a:r>
+            <a:r>
+              <a:rPr sz="2100" baseline="30000">
+                <a:latin typeface="Cambria"/>
+              </a:rPr>
+              <a:t>30</a:t>
+            </a:r>
+            <a:r>
+              <a:rPr sz="2100">
+                <a:latin typeface="Cambria"/>
+              </a:rPr>
+              <a:t> (1 − p)</a:t>
+            </a:r>
+            <a:r>
+              <a:rPr sz="2100" baseline="30000">
+                <a:latin typeface="Cambria"/>
+              </a:rPr>
+              <a:t>20</a:t>
             </a:r>
           </a:p>
         </p:txBody>
@@ -9163,106 +9022,6 @@
           </a:p>
         </p:txBody>
       </p:sp>
-      <p:graphicFrame>
-        <p:nvGraphicFramePr>
-          <p:cNvPr id="328706" name="Object 5"/>
-          <p:cNvGraphicFramePr>
-            <a:graphicFrameLocks noGrp="1" noChangeAspect="1"/>
-          </p:cNvGraphicFramePr>
-          <p:nvPr>
-            <p:ph sz="half" idx="1"/>
-            <p:extLst>
-              <p:ext uri="{D42A27DB-BD31-4B8C-83A1-F6EECF244321}">
-                <p14:modId xmlns:p14="http://schemas.microsoft.com/office/powerpoint/2010/main" val="3220316714"/>
-              </p:ext>
-            </p:extLst>
-          </p:nvPr>
-        </p:nvGraphicFramePr>
-        <p:xfrm>
-          <a:off x="1626825" y="3523796"/>
-          <a:ext cx="3433763" cy="406400"/>
-        </p:xfrm>
-        <a:graphic>
-          <a:graphicData uri="http://schemas.openxmlformats.org/presentationml/2006/ole">
-            <mc:AlternateContent xmlns:mc="http://schemas.openxmlformats.org/markup-compatibility/2006">
-              <mc:Choice xmlns:v="urn:schemas-microsoft-com:vml" Requires="v">
-                <p:oleObj name="Equation" r:id="rId3" imgW="1714500" imgH="203200" progId="Equation.DSMT4">
-                  <p:embed/>
-                </p:oleObj>
-              </mc:Choice>
-              <mc:Fallback>
-                <p:oleObj name="Equation" r:id="rId3" imgW="1714500" imgH="203200" progId="Equation.DSMT4">
-                  <p:embed/>
-                  <p:pic>
-                    <p:nvPicPr>
-                      <p:cNvPr id="0" name=""/>
-                      <p:cNvPicPr>
-                        <a:picLocks noChangeAspect="1" noChangeArrowheads="1"/>
-                      </p:cNvPicPr>
-                      <p:nvPr/>
-                    </p:nvPicPr>
-                    <p:blipFill>
-                      <a:blip r:embed="rId4">
-                        <a:extLst>
-                          <a:ext uri="{28A0092B-C50C-407E-A947-70E740481C1C}">
-                            <a14:useLocalDpi xmlns:a14="http://schemas.microsoft.com/office/drawing/2010/main" val="0"/>
-                          </a:ext>
-                        </a:extLst>
-                      </a:blip>
-                      <a:srcRect/>
-                      <a:stretch>
-                        <a:fillRect/>
-                      </a:stretch>
-                    </p:blipFill>
-                    <p:spPr bwMode="auto">
-                      <a:xfrm>
-                        <a:off x="1626825" y="3523796"/>
-                        <a:ext cx="3433763" cy="406400"/>
-                      </a:xfrm>
-                      <a:prstGeom prst="rect">
-                        <a:avLst/>
-                      </a:prstGeom>
-                      <a:noFill/>
-                      <a:ln>
-                        <a:noFill/>
-                      </a:ln>
-                      <a:effectLst/>
-                      <a:extLst>
-                        <a:ext uri="{909E8E84-426E-40DD-AFC4-6F175D3DCCD1}">
-                          <a14:hiddenFill xmlns:a14="http://schemas.microsoft.com/office/drawing/2010/main">
-                            <a:solidFill>
-                              <a:srgbClr val="FFFFFF"/>
-                            </a:solidFill>
-                          </a14:hiddenFill>
-                        </a:ext>
-                        <a:ext uri="{91240B29-F687-4F45-9708-019B960494DF}">
-                          <a14:hiddenLine xmlns:a14="http://schemas.microsoft.com/office/drawing/2010/main" w="9525">
-                            <a:solidFill>
-                              <a:srgbClr val="000000"/>
-                            </a:solidFill>
-                            <a:miter lim="800000"/>
-                            <a:headEnd/>
-                            <a:tailEnd/>
-                          </a14:hiddenLine>
-                        </a:ext>
-                        <a:ext uri="{AF507438-7753-43E0-B8FC-AC1667EBCBE1}">
-                          <a14:hiddenEffects xmlns:a14="http://schemas.microsoft.com/office/drawing/2010/main">
-                            <a:effectLst>
-                              <a:outerShdw dist="35921" dir="2700000" algn="ctr" rotWithShape="0">
-                                <a:srgbClr val="808080"/>
-                              </a:outerShdw>
-                            </a:effectLst>
-                          </a14:hiddenEffects>
-                        </a:ext>
-                      </a:extLst>
-                    </p:spPr>
-                  </p:pic>
-                </p:oleObj>
-              </mc:Fallback>
-            </mc:AlternateContent>
-          </a:graphicData>
-        </a:graphic>
-      </p:graphicFrame>
       <p:sp>
         <p:nvSpPr>
           <p:cNvPr id="22532" name="Text Box 4"/>
@@ -9662,111 +9421,21 @@
             </a:r>
             <a:r>
               <a:rPr lang="en-AU" altLang="en-US"/>
-              <a:t>,    , is again 0.6.</a:t>
+              <a:t>, </a:t>
+            </a:r>
+            <a:r>
+              <a:rPr lang="en-AU" altLang="en-US">
+                <a:latin typeface="Cambria"/>
+              </a:rPr>
+              <a:t>p̂</a:t>
+            </a:r>
+            <a:r>
+              <a:rPr lang="en-AU" altLang="en-US"/>
+              <a:t>, is again 0.6.</a:t>
             </a:r>
           </a:p>
         </p:txBody>
       </p:sp>
-      <p:graphicFrame>
-        <p:nvGraphicFramePr>
-          <p:cNvPr id="328710" name="Object 10"/>
-          <p:cNvGraphicFramePr>
-            <a:graphicFrameLocks noGrp="1" noChangeAspect="1"/>
-          </p:cNvGraphicFramePr>
-          <p:nvPr>
-            <p:ph sz="half" idx="2"/>
-            <p:extLst>
-              <p:ext uri="{D42A27DB-BD31-4B8C-83A1-F6EECF244321}">
-                <p14:modId xmlns:p14="http://schemas.microsoft.com/office/powerpoint/2010/main" val="4287000441"/>
-              </p:ext>
-            </p:extLst>
-          </p:nvPr>
-        </p:nvGraphicFramePr>
-        <p:xfrm>
-          <a:off x="3566993" y="4590596"/>
-          <a:ext cx="381000" cy="508000"/>
-        </p:xfrm>
-        <a:graphic>
-          <a:graphicData uri="http://schemas.openxmlformats.org/presentationml/2006/ole">
-            <mc:AlternateContent xmlns:mc="http://schemas.openxmlformats.org/markup-compatibility/2006">
-              <mc:Choice xmlns:v="urn:schemas-microsoft-com:vml" Requires="v">
-                <p:oleObj name="Equation" r:id="rId6" imgW="152268" imgH="203024" progId="Equation.DSMT4">
-                  <p:embed/>
-                </p:oleObj>
-              </mc:Choice>
-              <mc:Fallback>
-                <p:oleObj name="Equation" r:id="rId6" imgW="152268" imgH="203024" progId="Equation.DSMT4">
-                  <p:embed/>
-                  <p:pic>
-                    <p:nvPicPr>
-                      <p:cNvPr id="0" name=""/>
-                      <p:cNvPicPr>
-                        <a:picLocks noChangeAspect="1" noChangeArrowheads="1"/>
-                      </p:cNvPicPr>
-                      <p:nvPr/>
-                    </p:nvPicPr>
-                    <p:blipFill>
-                      <a:blip r:embed="rId7">
-                        <a:extLst>
-                          <a:ext uri="{28A0092B-C50C-407E-A947-70E740481C1C}">
-                            <a14:useLocalDpi xmlns:a14="http://schemas.microsoft.com/office/drawing/2010/main" val="0"/>
-                          </a:ext>
-                        </a:extLst>
-                      </a:blip>
-                      <a:srcRect/>
-                      <a:stretch>
-                        <a:fillRect/>
-                      </a:stretch>
-                    </p:blipFill>
-                    <p:spPr bwMode="auto">
-                      <a:xfrm>
-                        <a:off x="3566993" y="4590596"/>
-                        <a:ext cx="381000" cy="508000"/>
-                      </a:xfrm>
-                      <a:prstGeom prst="rect">
-                        <a:avLst/>
-                      </a:prstGeom>
-                      <a:noFill/>
-                      <a:ln>
-                        <a:noFill/>
-                      </a:ln>
-                      <a:effectLst/>
-                      <a:extLst>
-                        <a:ext uri="{909E8E84-426E-40DD-AFC4-6F175D3DCCD1}">
-                          <a14:hiddenFill xmlns:a14="http://schemas.microsoft.com/office/drawing/2010/main">
-                            <a:solidFill>
-                              <a:srgbClr val="FFFFFF"/>
-                            </a:solidFill>
-                          </a14:hiddenFill>
-                        </a:ext>
-                        <a:ext uri="{91240B29-F687-4F45-9708-019B960494DF}">
-                          <a14:hiddenLine xmlns:a14="http://schemas.microsoft.com/office/drawing/2010/main" w="9525">
-                            <a:solidFill>
-                              <a:srgbClr val="000000"/>
-                            </a:solidFill>
-                            <a:miter lim="800000"/>
-                            <a:headEnd/>
-                            <a:tailEnd/>
-                          </a14:hiddenLine>
-                        </a:ext>
-                        <a:ext uri="{AF507438-7753-43E0-B8FC-AC1667EBCBE1}">
-                          <a14:hiddenEffects xmlns:a14="http://schemas.microsoft.com/office/drawing/2010/main">
-                            <a:effectLst>
-                              <a:outerShdw dist="35921" dir="2700000" algn="ctr" rotWithShape="0">
-                                <a:srgbClr val="808080"/>
-                              </a:outerShdw>
-                            </a:effectLst>
-                          </a14:hiddenEffects>
-                        </a:ext>
-                      </a:extLst>
-                    </p:spPr>
-                  </p:pic>
-                </p:oleObj>
-              </mc:Fallback>
-            </mc:AlternateContent>
-          </a:graphicData>
-        </a:graphic>
-      </p:graphicFrame>
       <p:sp>
         <p:nvSpPr>
           <p:cNvPr id="9" name="Text Box 4"/>
@@ -9934,6 +9603,37 @@
               <a:t>for numerical optimizers</a:t>
             </a:r>
             <a:endParaRPr lang="en-AU" altLang="en-US" dirty="0"/>
+          </a:p>
+        </p:txBody>
+      </p:sp>
+      <p:sp>
+        <p:nvSpPr>
+          <p:cNvPr id="328711" name="TextBox 328710"/>
+          <p:cNvSpPr txBox="1"/>
+          <p:nvPr/>
+        </p:nvSpPr>
+        <p:spPr>
+          <a:xfrm>
+            <a:off x="1626825" y="3523796"/>
+            <a:ext cx="4360984" cy="406400"/>
+          </a:xfrm>
+          <a:prstGeom prst="rect">
+            <a:avLst/>
+          </a:prstGeom>
+          <a:noFill/>
+        </p:spPr>
+        <p:txBody>
+          <a:bodyPr wrap="square" anchor="ctr" lIns="0" rIns="0" tIns="0" bIns="0">
+            <a:spAutoFit/>
+          </a:bodyPr>
+          <a:lstStyle/>
+          <a:p>
+            <a:r>
+              <a:rPr sz="1900">
+                <a:latin typeface="Cambria"/>
+              </a:rPr>
+              <a:t>−ln L = −30 ln p − 20 ln(1 − p)</a:t>
+            </a:r>
           </a:p>
         </p:txBody>
       </p:sp>
@@ -10777,10 +10477,8 @@
               <a:t>mean blow rate for males be </a:t>
             </a:r>
             <a:r>
-              <a:rPr lang="en-AU" altLang="en-US" dirty="0">
-                <a:sym typeface="Symbol" charset="2"/>
-              </a:rPr>
-              <a:t></a:t>
+              <a:rPr lang="en-AU" altLang="en-US" dirty="0"/>
+              <a:t> λ</a:t>
             </a:r>
             <a:r>
               <a:rPr lang="en-AU" altLang="en-US" baseline="-25000" dirty="0">
@@ -10793,10 +10491,8 @@
               <a:t> and that for females be </a:t>
             </a:r>
             <a:r>
-              <a:rPr lang="en-AU" altLang="en-US" dirty="0">
-                <a:sym typeface="Symbol" charset="2"/>
-              </a:rPr>
-              <a:t></a:t>
+              <a:rPr lang="en-AU" altLang="en-US" dirty="0"/>
+              <a:t>λ</a:t>
             </a:r>
             <a:r>
               <a:rPr lang="en-AU" altLang="en-US" baseline="-25000" dirty="0">
@@ -10836,106 +10532,6 @@
           </a:p>
         </p:txBody>
       </p:sp>
-      <p:graphicFrame>
-        <p:nvGraphicFramePr>
-          <p:cNvPr id="338947" name="Object 5"/>
-          <p:cNvGraphicFramePr>
-            <a:graphicFrameLocks noGrp="1" noChangeAspect="1"/>
-          </p:cNvGraphicFramePr>
-          <p:nvPr>
-            <p:ph sz="half" idx="1"/>
-            <p:extLst>
-              <p:ext uri="{D42A27DB-BD31-4B8C-83A1-F6EECF244321}">
-                <p14:modId xmlns:p14="http://schemas.microsoft.com/office/powerpoint/2010/main" val="723641395"/>
-              </p:ext>
-            </p:extLst>
-          </p:nvPr>
-        </p:nvGraphicFramePr>
-        <p:xfrm>
-          <a:off x="4666861" y="2415074"/>
-          <a:ext cx="2058988" cy="838200"/>
-        </p:xfrm>
-        <a:graphic>
-          <a:graphicData uri="http://schemas.openxmlformats.org/presentationml/2006/ole">
-            <mc:AlternateContent xmlns:mc="http://schemas.openxmlformats.org/markup-compatibility/2006">
-              <mc:Choice xmlns:v="urn:schemas-microsoft-com:vml" Requires="v">
-                <p:oleObj name="Equation" r:id="rId3" imgW="1028700" imgH="419100" progId="Equation.DSMT4">
-                  <p:embed/>
-                </p:oleObj>
-              </mc:Choice>
-              <mc:Fallback>
-                <p:oleObj name="Equation" r:id="rId3" imgW="1028700" imgH="419100" progId="Equation.DSMT4">
-                  <p:embed/>
-                  <p:pic>
-                    <p:nvPicPr>
-                      <p:cNvPr id="0" name=""/>
-                      <p:cNvPicPr>
-                        <a:picLocks noChangeAspect="1" noChangeArrowheads="1"/>
-                      </p:cNvPicPr>
-                      <p:nvPr/>
-                    </p:nvPicPr>
-                    <p:blipFill>
-                      <a:blip r:embed="rId4">
-                        <a:extLst>
-                          <a:ext uri="{28A0092B-C50C-407E-A947-70E740481C1C}">
-                            <a14:useLocalDpi xmlns:a14="http://schemas.microsoft.com/office/drawing/2010/main" val="0"/>
-                          </a:ext>
-                        </a:extLst>
-                      </a:blip>
-                      <a:srcRect/>
-                      <a:stretch>
-                        <a:fillRect/>
-                      </a:stretch>
-                    </p:blipFill>
-                    <p:spPr bwMode="auto">
-                      <a:xfrm>
-                        <a:off x="4666861" y="2415074"/>
-                        <a:ext cx="2058988" cy="838200"/>
-                      </a:xfrm>
-                      <a:prstGeom prst="rect">
-                        <a:avLst/>
-                      </a:prstGeom>
-                      <a:noFill/>
-                      <a:ln>
-                        <a:noFill/>
-                      </a:ln>
-                      <a:effectLst/>
-                      <a:extLst>
-                        <a:ext uri="{909E8E84-426E-40DD-AFC4-6F175D3DCCD1}">
-                          <a14:hiddenFill xmlns:a14="http://schemas.microsoft.com/office/drawing/2010/main">
-                            <a:solidFill>
-                              <a:srgbClr val="FFFFFF"/>
-                            </a:solidFill>
-                          </a14:hiddenFill>
-                        </a:ext>
-                        <a:ext uri="{91240B29-F687-4F45-9708-019B960494DF}">
-                          <a14:hiddenLine xmlns:a14="http://schemas.microsoft.com/office/drawing/2010/main" w="9525">
-                            <a:solidFill>
-                              <a:srgbClr val="000000"/>
-                            </a:solidFill>
-                            <a:miter lim="800000"/>
-                            <a:headEnd/>
-                            <a:tailEnd/>
-                          </a14:hiddenLine>
-                        </a:ext>
-                        <a:ext uri="{AF507438-7753-43E0-B8FC-AC1667EBCBE1}">
-                          <a14:hiddenEffects xmlns:a14="http://schemas.microsoft.com/office/drawing/2010/main">
-                            <a:effectLst>
-                              <a:outerShdw dist="35921" dir="2700000" algn="ctr" rotWithShape="0">
-                                <a:srgbClr val="808080"/>
-                              </a:outerShdw>
-                            </a:effectLst>
-                          </a14:hiddenEffects>
-                        </a:ext>
-                      </a:extLst>
-                    </p:spPr>
-                  </p:pic>
-                </p:oleObj>
-              </mc:Fallback>
-            </mc:AlternateContent>
-          </a:graphicData>
-        </a:graphic>
-      </p:graphicFrame>
       <p:sp>
         <p:nvSpPr>
           <p:cNvPr id="7173" name="Text Box 4"/>
@@ -11101,106 +10697,6 @@
           </a:p>
         </p:txBody>
       </p:sp>
-      <p:graphicFrame>
-        <p:nvGraphicFramePr>
-          <p:cNvPr id="338949" name="Object 8"/>
-          <p:cNvGraphicFramePr>
-            <a:graphicFrameLocks noGrp="1" noChangeAspect="1"/>
-          </p:cNvGraphicFramePr>
-          <p:nvPr>
-            <p:ph sz="half" idx="2"/>
-            <p:extLst>
-              <p:ext uri="{D42A27DB-BD31-4B8C-83A1-F6EECF244321}">
-                <p14:modId xmlns:p14="http://schemas.microsoft.com/office/powerpoint/2010/main" val="1041032804"/>
-              </p:ext>
-            </p:extLst>
-          </p:nvPr>
-        </p:nvGraphicFramePr>
-        <p:xfrm>
-          <a:off x="3174611" y="4701075"/>
-          <a:ext cx="4984750" cy="835025"/>
-        </p:xfrm>
-        <a:graphic>
-          <a:graphicData uri="http://schemas.openxmlformats.org/presentationml/2006/ole">
-            <mc:AlternateContent xmlns:mc="http://schemas.openxmlformats.org/markup-compatibility/2006">
-              <mc:Choice xmlns:v="urn:schemas-microsoft-com:vml" Requires="v">
-                <p:oleObj name="Equation" r:id="rId5" imgW="2501900" imgH="419100" progId="Equation.DSMT4">
-                  <p:embed/>
-                </p:oleObj>
-              </mc:Choice>
-              <mc:Fallback>
-                <p:oleObj name="Equation" r:id="rId5" imgW="2501900" imgH="419100" progId="Equation.DSMT4">
-                  <p:embed/>
-                  <p:pic>
-                    <p:nvPicPr>
-                      <p:cNvPr id="0" name=""/>
-                      <p:cNvPicPr>
-                        <a:picLocks noChangeAspect="1" noChangeArrowheads="1"/>
-                      </p:cNvPicPr>
-                      <p:nvPr/>
-                    </p:nvPicPr>
-                    <p:blipFill>
-                      <a:blip r:embed="rId6">
-                        <a:extLst>
-                          <a:ext uri="{28A0092B-C50C-407E-A947-70E740481C1C}">
-                            <a14:useLocalDpi xmlns:a14="http://schemas.microsoft.com/office/drawing/2010/main" val="0"/>
-                          </a:ext>
-                        </a:extLst>
-                      </a:blip>
-                      <a:srcRect/>
-                      <a:stretch>
-                        <a:fillRect/>
-                      </a:stretch>
-                    </p:blipFill>
-                    <p:spPr bwMode="auto">
-                      <a:xfrm>
-                        <a:off x="3174611" y="4701075"/>
-                        <a:ext cx="4984750" cy="835025"/>
-                      </a:xfrm>
-                      <a:prstGeom prst="rect">
-                        <a:avLst/>
-                      </a:prstGeom>
-                      <a:noFill/>
-                      <a:ln>
-                        <a:noFill/>
-                      </a:ln>
-                      <a:effectLst/>
-                      <a:extLst>
-                        <a:ext uri="{909E8E84-426E-40DD-AFC4-6F175D3DCCD1}">
-                          <a14:hiddenFill xmlns:a14="http://schemas.microsoft.com/office/drawing/2010/main">
-                            <a:solidFill>
-                              <a:srgbClr val="FFFFFF"/>
-                            </a:solidFill>
-                          </a14:hiddenFill>
-                        </a:ext>
-                        <a:ext uri="{91240B29-F687-4F45-9708-019B960494DF}">
-                          <a14:hiddenLine xmlns:a14="http://schemas.microsoft.com/office/drawing/2010/main" w="9525">
-                            <a:solidFill>
-                              <a:srgbClr val="000000"/>
-                            </a:solidFill>
-                            <a:miter lim="800000"/>
-                            <a:headEnd/>
-                            <a:tailEnd/>
-                          </a14:hiddenLine>
-                        </a:ext>
-                        <a:ext uri="{AF507438-7753-43E0-B8FC-AC1667EBCBE1}">
-                          <a14:hiddenEffects xmlns:a14="http://schemas.microsoft.com/office/drawing/2010/main">
-                            <a:effectLst>
-                              <a:outerShdw dist="35921" dir="2700000" algn="ctr" rotWithShape="0">
-                                <a:srgbClr val="808080"/>
-                              </a:outerShdw>
-                            </a:effectLst>
-                          </a14:hiddenEffects>
-                        </a:ext>
-                      </a:extLst>
-                    </p:spPr>
-                  </p:pic>
-                </p:oleObj>
-              </mc:Fallback>
-            </mc:AlternateContent>
-          </a:graphicData>
-        </a:graphic>
-      </p:graphicFrame>
       <p:sp>
         <p:nvSpPr>
           <p:cNvPr id="7175" name="Slide Number Placeholder 1"/>
@@ -11628,6 +11124,164 @@
             <a:r>
               <a:rPr lang="en-AU" altLang="en-US" dirty="0"/>
               <a:t>How would you do this with linear models?</a:t>
+            </a:r>
+          </a:p>
+        </p:txBody>
+      </p:sp>
+      <p:sp>
+        <p:nvSpPr>
+          <p:cNvPr id="338950" name="TextBox 338949"/>
+          <p:cNvSpPr txBox="1"/>
+          <p:nvPr/>
+        </p:nvSpPr>
+        <p:spPr>
+          <a:xfrm>
+            <a:off x="4666861" y="2415074"/>
+            <a:ext cx="3657600" cy="838200"/>
+          </a:xfrm>
+          <a:prstGeom prst="rect">
+            <a:avLst/>
+          </a:prstGeom>
+          <a:noFill/>
+        </p:spPr>
+        <p:txBody>
+          <a:bodyPr wrap="square" anchor="ctr" lIns="0" rIns="0" tIns="0" bIns="0">
+            <a:spAutoFit/>
+          </a:bodyPr>
+          <a:lstStyle/>
+          <a:p>
+            <a:r>
+              <a:rPr sz="2000">
+                <a:latin typeface="Cambria"/>
+              </a:rPr>
+              <a:t>P(x | λ) = λ</a:t>
+            </a:r>
+            <a:r>
+              <a:rPr sz="2000" baseline="30000">
+                <a:latin typeface="Cambria"/>
+              </a:rPr>
+              <a:t>x</a:t>
+            </a:r>
+            <a:r>
+              <a:rPr sz="2000">
+                <a:latin typeface="Cambria"/>
+              </a:rPr>
+              <a:t> exp(−λ) / x!</a:t>
+            </a:r>
+          </a:p>
+        </p:txBody>
+      </p:sp>
+      <p:sp>
+        <p:nvSpPr>
+          <p:cNvPr id="338951" name="TextBox 338950"/>
+          <p:cNvSpPr txBox="1"/>
+          <p:nvPr/>
+        </p:nvSpPr>
+        <p:spPr>
+          <a:xfrm>
+            <a:off x="3174611" y="4701075"/>
+            <a:ext cx="8834509" cy="835025"/>
+          </a:xfrm>
+          <a:prstGeom prst="rect">
+            <a:avLst/>
+          </a:prstGeom>
+          <a:noFill/>
+        </p:spPr>
+        <p:txBody>
+          <a:bodyPr wrap="square" anchor="ctr" lIns="0" rIns="0" tIns="0" bIns="0">
+            <a:spAutoFit/>
+          </a:bodyPr>
+          <a:lstStyle/>
+          <a:p>
+            <a:r>
+              <a:rPr sz="1900">
+                <a:latin typeface="Cambria"/>
+              </a:rPr>
+              <a:t>P(x | p, λ</a:t>
+            </a:r>
+            <a:r>
+              <a:rPr sz="1900" baseline="-25000">
+                <a:latin typeface="Cambria"/>
+              </a:rPr>
+              <a:t>1</a:t>
+            </a:r>
+            <a:r>
+              <a:rPr sz="1900">
+                <a:latin typeface="Cambria"/>
+              </a:rPr>
+              <a:t>, λ</a:t>
+            </a:r>
+            <a:r>
+              <a:rPr sz="1900" baseline="-25000">
+                <a:latin typeface="Cambria"/>
+              </a:rPr>
+              <a:t>2</a:t>
+            </a:r>
+            <a:r>
+              <a:rPr sz="1900">
+                <a:latin typeface="Cambria"/>
+              </a:rPr>
+              <a:t>) = p λ</a:t>
+            </a:r>
+            <a:r>
+              <a:rPr sz="1900" baseline="-25000">
+                <a:latin typeface="Cambria"/>
+              </a:rPr>
+              <a:t>1</a:t>
+            </a:r>
+            <a:r>
+              <a:rPr sz="1900" baseline="30000">
+                <a:latin typeface="Cambria"/>
+              </a:rPr>
+              <a:t>x</a:t>
+            </a:r>
+            <a:r>
+              <a:rPr sz="1900">
+                <a:latin typeface="Cambria"/>
+              </a:rPr>
+              <a:t> exp(−λ</a:t>
+            </a:r>
+            <a:r>
+              <a:rPr sz="1900" baseline="-25000">
+                <a:latin typeface="Cambria"/>
+              </a:rPr>
+              <a:t>1</a:t>
+            </a:r>
+            <a:r>
+              <a:rPr sz="1900">
+                <a:latin typeface="Cambria"/>
+              </a:rPr>
+              <a:t>) / x! + (1 − p) λ</a:t>
+            </a:r>
+            <a:r>
+              <a:rPr sz="1900" baseline="-25000">
+                <a:latin typeface="Cambria"/>
+              </a:rPr>
+              <a:t>2</a:t>
+            </a:r>
+            <a:r>
+              <a:rPr sz="1900" baseline="30000">
+                <a:latin typeface="Cambria"/>
+              </a:rPr>
+              <a:t>x</a:t>
+            </a:r>
+            <a:r>
+              <a:rPr sz="1900">
+                <a:latin typeface="Cambria"/>
+              </a:rPr>
+              <a:t> exp(−λ</a:t>
+            </a:r>
+            <a:r>
+              <a:rPr sz="1900" baseline="-25000">
+                <a:latin typeface="Cambria"/>
+              </a:rPr>
+              <a:t>2</a:t>
+            </a:r>
+            <a:r>
+              <a:rPr sz="1900">
+                <a:latin typeface="Cambria"/>
+              </a:rPr>
+              <a:t>) / x!</a:t>
             </a:r>
           </a:p>
         </p:txBody>
@@ -11701,10 +11355,8 @@
               <a:t>is</a:t>
             </a:r>
             <a:r>
-              <a:rPr lang="en-AU" dirty="0" err="1">
-                <a:sym typeface="Symbol"/>
-              </a:rPr>
-              <a:t></a:t>
+              <a:rPr lang="en-AU" dirty="0" err="1"/>
+              <a:t> </a:t>
             </a:r>
             <a:r>
               <a:rPr lang="en-AU" i="1" dirty="0" err="1">
@@ -11940,106 +11592,6 @@
           <a:chExt cx="0" cy="0"/>
         </a:xfrm>
       </p:grpSpPr>
-      <p:graphicFrame>
-        <p:nvGraphicFramePr>
-          <p:cNvPr id="343042" name="Object 5"/>
-          <p:cNvGraphicFramePr>
-            <a:graphicFrameLocks noGrp="1" noChangeAspect="1"/>
-          </p:cNvGraphicFramePr>
-          <p:nvPr>
-            <p:ph sz="half" idx="1"/>
-            <p:extLst>
-              <p:ext uri="{D42A27DB-BD31-4B8C-83A1-F6EECF244321}">
-                <p14:modId xmlns:p14="http://schemas.microsoft.com/office/powerpoint/2010/main" val="1375761377"/>
-              </p:ext>
-            </p:extLst>
-          </p:nvPr>
-        </p:nvGraphicFramePr>
-        <p:xfrm>
-          <a:off x="3161717" y="2354425"/>
-          <a:ext cx="5816600" cy="965200"/>
-        </p:xfrm>
-        <a:graphic>
-          <a:graphicData uri="http://schemas.openxmlformats.org/presentationml/2006/ole">
-            <mc:AlternateContent xmlns:mc="http://schemas.openxmlformats.org/markup-compatibility/2006">
-              <mc:Choice xmlns:v="urn:schemas-microsoft-com:vml" Requires="v">
-                <p:oleObj name="Equation" r:id="rId3" imgW="2908300" imgH="482600" progId="Equation.DSMT4">
-                  <p:embed/>
-                </p:oleObj>
-              </mc:Choice>
-              <mc:Fallback>
-                <p:oleObj name="Equation" r:id="rId3" imgW="2908300" imgH="482600" progId="Equation.DSMT4">
-                  <p:embed/>
-                  <p:pic>
-                    <p:nvPicPr>
-                      <p:cNvPr id="0" name=""/>
-                      <p:cNvPicPr>
-                        <a:picLocks noChangeAspect="1" noChangeArrowheads="1"/>
-                      </p:cNvPicPr>
-                      <p:nvPr/>
-                    </p:nvPicPr>
-                    <p:blipFill>
-                      <a:blip r:embed="rId4">
-                        <a:extLst>
-                          <a:ext uri="{28A0092B-C50C-407E-A947-70E740481C1C}">
-                            <a14:useLocalDpi xmlns:a14="http://schemas.microsoft.com/office/drawing/2010/main" val="0"/>
-                          </a:ext>
-                        </a:extLst>
-                      </a:blip>
-                      <a:srcRect/>
-                      <a:stretch>
-                        <a:fillRect/>
-                      </a:stretch>
-                    </p:blipFill>
-                    <p:spPr bwMode="auto">
-                      <a:xfrm>
-                        <a:off x="3161717" y="2354425"/>
-                        <a:ext cx="5816600" cy="965200"/>
-                      </a:xfrm>
-                      <a:prstGeom prst="rect">
-                        <a:avLst/>
-                      </a:prstGeom>
-                      <a:noFill/>
-                      <a:ln>
-                        <a:noFill/>
-                      </a:ln>
-                      <a:effectLst/>
-                      <a:extLst>
-                        <a:ext uri="{909E8E84-426E-40DD-AFC4-6F175D3DCCD1}">
-                          <a14:hiddenFill xmlns:a14="http://schemas.microsoft.com/office/drawing/2010/main">
-                            <a:solidFill>
-                              <a:srgbClr val="FFFFFF"/>
-                            </a:solidFill>
-                          </a14:hiddenFill>
-                        </a:ext>
-                        <a:ext uri="{91240B29-F687-4F45-9708-019B960494DF}">
-                          <a14:hiddenLine xmlns:a14="http://schemas.microsoft.com/office/drawing/2010/main" w="9525">
-                            <a:solidFill>
-                              <a:srgbClr val="000000"/>
-                            </a:solidFill>
-                            <a:miter lim="800000"/>
-                            <a:headEnd/>
-                            <a:tailEnd/>
-                          </a14:hiddenLine>
-                        </a:ext>
-                        <a:ext uri="{AF507438-7753-43E0-B8FC-AC1667EBCBE1}">
-                          <a14:hiddenEffects xmlns:a14="http://schemas.microsoft.com/office/drawing/2010/main">
-                            <a:effectLst>
-                              <a:outerShdw dist="35921" dir="2700000" algn="ctr" rotWithShape="0">
-                                <a:srgbClr val="808080"/>
-                              </a:outerShdw>
-                            </a:effectLst>
-                          </a14:hiddenEffects>
-                        </a:ext>
-                      </a:extLst>
-                    </p:spPr>
-                  </p:pic>
-                </p:oleObj>
-              </mc:Fallback>
-            </mc:AlternateContent>
-          </a:graphicData>
-        </a:graphic>
-      </p:graphicFrame>
       <p:sp>
         <p:nvSpPr>
           <p:cNvPr id="9220" name="Text Box 4"/>
@@ -12395,106 +11947,6 @@
           </a:p>
         </p:txBody>
       </p:sp>
-      <p:graphicFrame>
-        <p:nvGraphicFramePr>
-          <p:cNvPr id="343045" name="Object 8"/>
-          <p:cNvGraphicFramePr>
-            <a:graphicFrameLocks noGrp="1" noChangeAspect="1"/>
-          </p:cNvGraphicFramePr>
-          <p:nvPr>
-            <p:ph sz="half" idx="2"/>
-            <p:extLst>
-              <p:ext uri="{D42A27DB-BD31-4B8C-83A1-F6EECF244321}">
-                <p14:modId xmlns:p14="http://schemas.microsoft.com/office/powerpoint/2010/main" val="465035990"/>
-              </p:ext>
-            </p:extLst>
-          </p:nvPr>
-        </p:nvGraphicFramePr>
-        <p:xfrm>
-          <a:off x="4904792" y="4259425"/>
-          <a:ext cx="2058988" cy="838200"/>
-        </p:xfrm>
-        <a:graphic>
-          <a:graphicData uri="http://schemas.openxmlformats.org/presentationml/2006/ole">
-            <mc:AlternateContent xmlns:mc="http://schemas.openxmlformats.org/markup-compatibility/2006">
-              <mc:Choice xmlns:v="urn:schemas-microsoft-com:vml" Requires="v">
-                <p:oleObj name="Equation" r:id="rId5" imgW="1028700" imgH="419100" progId="Equation.DSMT4">
-                  <p:embed/>
-                </p:oleObj>
-              </mc:Choice>
-              <mc:Fallback>
-                <p:oleObj name="Equation" r:id="rId5" imgW="1028700" imgH="419100" progId="Equation.DSMT4">
-                  <p:embed/>
-                  <p:pic>
-                    <p:nvPicPr>
-                      <p:cNvPr id="0" name=""/>
-                      <p:cNvPicPr>
-                        <a:picLocks noChangeAspect="1" noChangeArrowheads="1"/>
-                      </p:cNvPicPr>
-                      <p:nvPr/>
-                    </p:nvPicPr>
-                    <p:blipFill>
-                      <a:blip r:embed="rId6">
-                        <a:extLst>
-                          <a:ext uri="{28A0092B-C50C-407E-A947-70E740481C1C}">
-                            <a14:useLocalDpi xmlns:a14="http://schemas.microsoft.com/office/drawing/2010/main" val="0"/>
-                          </a:ext>
-                        </a:extLst>
-                      </a:blip>
-                      <a:srcRect/>
-                      <a:stretch>
-                        <a:fillRect/>
-                      </a:stretch>
-                    </p:blipFill>
-                    <p:spPr bwMode="auto">
-                      <a:xfrm>
-                        <a:off x="4904792" y="4259425"/>
-                        <a:ext cx="2058988" cy="838200"/>
-                      </a:xfrm>
-                      <a:prstGeom prst="rect">
-                        <a:avLst/>
-                      </a:prstGeom>
-                      <a:noFill/>
-                      <a:ln>
-                        <a:noFill/>
-                      </a:ln>
-                      <a:effectLst/>
-                      <a:extLst>
-                        <a:ext uri="{909E8E84-426E-40DD-AFC4-6F175D3DCCD1}">
-                          <a14:hiddenFill xmlns:a14="http://schemas.microsoft.com/office/drawing/2010/main">
-                            <a:solidFill>
-                              <a:srgbClr val="FFFFFF"/>
-                            </a:solidFill>
-                          </a14:hiddenFill>
-                        </a:ext>
-                        <a:ext uri="{91240B29-F687-4F45-9708-019B960494DF}">
-                          <a14:hiddenLine xmlns:a14="http://schemas.microsoft.com/office/drawing/2010/main" w="9525">
-                            <a:solidFill>
-                              <a:srgbClr val="000000"/>
-                            </a:solidFill>
-                            <a:miter lim="800000"/>
-                            <a:headEnd/>
-                            <a:tailEnd/>
-                          </a14:hiddenLine>
-                        </a:ext>
-                        <a:ext uri="{AF507438-7753-43E0-B8FC-AC1667EBCBE1}">
-                          <a14:hiddenEffects xmlns:a14="http://schemas.microsoft.com/office/drawing/2010/main">
-                            <a:effectLst>
-                              <a:outerShdw dist="35921" dir="2700000" algn="ctr" rotWithShape="0">
-                                <a:srgbClr val="808080"/>
-                              </a:outerShdw>
-                            </a:effectLst>
-                          </a14:hiddenEffects>
-                        </a:ext>
-                      </a:extLst>
-                    </p:spPr>
-                  </p:pic>
-                </p:oleObj>
-              </mc:Fallback>
-            </mc:AlternateContent>
-          </a:graphicData>
-        </a:graphic>
-      </p:graphicFrame>
       <p:sp>
         <p:nvSpPr>
           <p:cNvPr id="9223" name="Slide Number Placeholder 1"/>
@@ -12632,6 +12084,200 @@
               <a:t>18</a:t>
             </a:fld>
             <a:endParaRPr lang="en-US" altLang="en-US" sz="1400"/>
+          </a:p>
+        </p:txBody>
+      </p:sp>
+      <p:sp>
+        <p:nvSpPr>
+          <p:cNvPr id="343046" name="TextBox 343045"/>
+          <p:cNvSpPr txBox="1"/>
+          <p:nvPr/>
+        </p:nvSpPr>
+        <p:spPr>
+          <a:xfrm>
+            <a:off x="3161717" y="2354425"/>
+            <a:ext cx="8847403" cy="965200"/>
+          </a:xfrm>
+          <a:prstGeom prst="rect">
+            <a:avLst/>
+          </a:prstGeom>
+          <a:noFill/>
+        </p:spPr>
+        <p:txBody>
+          <a:bodyPr wrap="square" anchor="ctr" lIns="0" rIns="0" tIns="0" bIns="0">
+            <a:spAutoFit/>
+          </a:bodyPr>
+          <a:lstStyle/>
+          <a:p>
+            <a:r>
+              <a:rPr sz="1600">
+                <a:latin typeface="Cambria"/>
+              </a:rPr>
+              <a:t>P(x | p, λ</a:t>
+            </a:r>
+            <a:r>
+              <a:rPr sz="1600" baseline="-25000">
+                <a:latin typeface="Cambria"/>
+              </a:rPr>
+              <a:t>1</a:t>
+            </a:r>
+            <a:r>
+              <a:rPr sz="1600">
+                <a:latin typeface="Cambria"/>
+              </a:rPr>
+              <a:t>, λ</a:t>
+            </a:r>
+            <a:r>
+              <a:rPr sz="1600" baseline="-25000">
+                <a:latin typeface="Cambria"/>
+              </a:rPr>
+              <a:t>2</a:t>
+            </a:r>
+            <a:r>
+              <a:rPr sz="1600">
+                <a:latin typeface="Cambria"/>
+              </a:rPr>
+              <a:t>) = ∏</a:t>
+            </a:r>
+            <a:r>
+              <a:rPr sz="1600" baseline="-25000">
+                <a:latin typeface="Cambria"/>
+              </a:rPr>
+              <a:t>i</a:t>
+            </a:r>
+            <a:r>
+              <a:rPr sz="1600">
+                <a:latin typeface="Cambria"/>
+              </a:rPr>
+              <a:t> ( p λ</a:t>
+            </a:r>
+            <a:r>
+              <a:rPr sz="1600" baseline="-25000">
+                <a:latin typeface="Cambria"/>
+              </a:rPr>
+              <a:t>1</a:t>
+            </a:r>
+            <a:r>
+              <a:rPr sz="1600" baseline="30000">
+                <a:latin typeface="Cambria"/>
+              </a:rPr>
+              <a:t>xᵢ</a:t>
+            </a:r>
+            <a:r>
+              <a:rPr sz="1600">
+                <a:latin typeface="Cambria"/>
+              </a:rPr>
+              <a:t> exp(−λ</a:t>
+            </a:r>
+            <a:r>
+              <a:rPr sz="1600" baseline="-25000">
+                <a:latin typeface="Cambria"/>
+              </a:rPr>
+              <a:t>1</a:t>
+            </a:r>
+            <a:r>
+              <a:rPr sz="1600">
+                <a:latin typeface="Cambria"/>
+              </a:rPr>
+              <a:t>) / x</a:t>
+            </a:r>
+            <a:r>
+              <a:rPr sz="1600" baseline="-25000">
+                <a:latin typeface="Cambria"/>
+              </a:rPr>
+              <a:t>i</a:t>
+            </a:r>
+            <a:r>
+              <a:rPr sz="1600">
+                <a:latin typeface="Cambria"/>
+              </a:rPr>
+              <a:t>! + (1 − p) λ</a:t>
+            </a:r>
+            <a:r>
+              <a:rPr sz="1600" baseline="-25000">
+                <a:latin typeface="Cambria"/>
+              </a:rPr>
+              <a:t>2</a:t>
+            </a:r>
+            <a:r>
+              <a:rPr sz="1600" baseline="30000">
+                <a:latin typeface="Cambria"/>
+              </a:rPr>
+              <a:t>xᵢ</a:t>
+            </a:r>
+            <a:r>
+              <a:rPr sz="1600">
+                <a:latin typeface="Cambria"/>
+              </a:rPr>
+              <a:t> exp(−λ</a:t>
+            </a:r>
+            <a:r>
+              <a:rPr sz="1600" baseline="-25000">
+                <a:latin typeface="Cambria"/>
+              </a:rPr>
+              <a:t>2</a:t>
+            </a:r>
+            <a:r>
+              <a:rPr sz="1600">
+                <a:latin typeface="Cambria"/>
+              </a:rPr>
+              <a:t>) / x</a:t>
+            </a:r>
+            <a:r>
+              <a:rPr sz="1600" baseline="-25000">
+                <a:latin typeface="Cambria"/>
+              </a:rPr>
+              <a:t>i</a:t>
+            </a:r>
+            <a:r>
+              <a:rPr sz="1600">
+                <a:latin typeface="Cambria"/>
+              </a:rPr>
+              <a:t>! )</a:t>
+            </a:r>
+          </a:p>
+        </p:txBody>
+      </p:sp>
+      <p:sp>
+        <p:nvSpPr>
+          <p:cNvPr id="343047" name="TextBox 343046"/>
+          <p:cNvSpPr txBox="1"/>
+          <p:nvPr/>
+        </p:nvSpPr>
+        <p:spPr>
+          <a:xfrm>
+            <a:off x="4904792" y="4259425"/>
+            <a:ext cx="3657600" cy="838200"/>
+          </a:xfrm>
+          <a:prstGeom prst="rect">
+            <a:avLst/>
+          </a:prstGeom>
+          <a:noFill/>
+        </p:spPr>
+        <p:txBody>
+          <a:bodyPr wrap="square" anchor="ctr" lIns="0" rIns="0" tIns="0" bIns="0">
+            <a:spAutoFit/>
+          </a:bodyPr>
+          <a:lstStyle/>
+          <a:p>
+            <a:r>
+              <a:rPr sz="2000">
+                <a:latin typeface="Cambria"/>
+              </a:rPr>
+              <a:t>P(x | λ) = λ</a:t>
+            </a:r>
+            <a:r>
+              <a:rPr sz="2000" baseline="30000">
+                <a:latin typeface="Cambria"/>
+              </a:rPr>
+              <a:t>x</a:t>
+            </a:r>
+            <a:r>
+              <a:rPr sz="2000">
+                <a:latin typeface="Cambria"/>
+              </a:rPr>
+              <a:t> exp(−λ) / x!</a:t>
+            </a:r>
           </a:p>
         </p:txBody>
       </p:sp>
@@ -19025,9 +18671,8 @@
                 <a:solidFill>
                   <a:srgbClr val="000000"/>
                 </a:solidFill>
-                <a:sym typeface="Symbol" charset="2"/>
               </a:rPr>
-              <a:t></a:t>
+              <a:t> λ</a:t>
             </a:r>
             <a:r>
               <a:rPr lang="en-AU" altLang="en-US" baseline="-25000" dirty="0">
@@ -19051,9 +18696,8 @@
                 <a:solidFill>
                   <a:srgbClr val="000000"/>
                 </a:solidFill>
-                <a:sym typeface="Symbol" charset="2"/>
               </a:rPr>
-              <a:t></a:t>
+              <a:t>λ</a:t>
             </a:r>
             <a:r>
               <a:rPr lang="en-AU" altLang="en-US" baseline="-25000" dirty="0">
@@ -19108,101 +18752,6 @@
           </a:p>
         </p:txBody>
       </p:sp>
-      <p:graphicFrame>
-        <p:nvGraphicFramePr>
-          <p:cNvPr id="32770" name="Object 5"/>
-          <p:cNvGraphicFramePr>
-            <a:graphicFrameLocks noGrp="1" noChangeAspect="1"/>
-          </p:cNvGraphicFramePr>
-          <p:nvPr>
-            <p:ph sz="half" idx="1"/>
-          </p:nvPr>
-        </p:nvGraphicFramePr>
-        <p:xfrm>
-          <a:off x="5105400" y="1752600"/>
-          <a:ext cx="2058988" cy="838200"/>
-        </p:xfrm>
-        <a:graphic>
-          <a:graphicData uri="http://schemas.openxmlformats.org/presentationml/2006/ole">
-            <mc:AlternateContent xmlns:mc="http://schemas.openxmlformats.org/markup-compatibility/2006">
-              <mc:Choice xmlns:v="urn:schemas-microsoft-com:vml" Requires="v">
-                <p:oleObj name="Equation" r:id="rId3" imgW="1028700" imgH="419100" progId="Equation.DSMT4">
-                  <p:embed/>
-                </p:oleObj>
-              </mc:Choice>
-              <mc:Fallback>
-                <p:oleObj name="Equation" r:id="rId3" imgW="1028700" imgH="419100" progId="Equation.DSMT4">
-                  <p:embed/>
-                  <p:pic>
-                    <p:nvPicPr>
-                      <p:cNvPr id="0" name=""/>
-                      <p:cNvPicPr>
-                        <a:picLocks noChangeAspect="1" noChangeArrowheads="1"/>
-                      </p:cNvPicPr>
-                      <p:nvPr/>
-                    </p:nvPicPr>
-                    <p:blipFill>
-                      <a:blip r:embed="rId4">
-                        <a:extLst>
-                          <a:ext uri="{28A0092B-C50C-407E-A947-70E740481C1C}">
-                            <a14:useLocalDpi xmlns:a14="http://schemas.microsoft.com/office/drawing/2010/main" val="0"/>
-                          </a:ext>
-                        </a:extLst>
-                      </a:blip>
-                      <a:srcRect/>
-                      <a:stretch>
-                        <a:fillRect/>
-                      </a:stretch>
-                    </p:blipFill>
-                    <p:spPr bwMode="auto">
-                      <a:xfrm>
-                        <a:off x="5105400" y="1752600"/>
-                        <a:ext cx="2058988" cy="838200"/>
-                      </a:xfrm>
-                      <a:prstGeom prst="rect">
-                        <a:avLst/>
-                      </a:prstGeom>
-                      <a:noFill/>
-                      <a:ln>
-                        <a:noFill/>
-                      </a:ln>
-                      <a:effectLst/>
-                      <a:extLst>
-                        <a:ext uri="{909E8E84-426E-40DD-AFC4-6F175D3DCCD1}">
-                          <a14:hiddenFill xmlns:a14="http://schemas.microsoft.com/office/drawing/2010/main">
-                            <a:solidFill>
-                              <a:srgbClr val="FFFFFF"/>
-                            </a:solidFill>
-                          </a14:hiddenFill>
-                        </a:ext>
-                        <a:ext uri="{91240B29-F687-4F45-9708-019B960494DF}">
-                          <a14:hiddenLine xmlns:a14="http://schemas.microsoft.com/office/drawing/2010/main" w="9525">
-                            <a:solidFill>
-                              <a:srgbClr val="000000"/>
-                            </a:solidFill>
-                            <a:miter lim="800000"/>
-                            <a:headEnd/>
-                            <a:tailEnd/>
-                          </a14:hiddenLine>
-                        </a:ext>
-                        <a:ext uri="{AF507438-7753-43E0-B8FC-AC1667EBCBE1}">
-                          <a14:hiddenEffects xmlns:a14="http://schemas.microsoft.com/office/drawing/2010/main">
-                            <a:effectLst>
-                              <a:outerShdw dist="35921" dir="2700000" algn="ctr" rotWithShape="0">
-                                <a:srgbClr val="808080"/>
-                              </a:outerShdw>
-                            </a:effectLst>
-                          </a14:hiddenEffects>
-                        </a:ext>
-                      </a:extLst>
-                    </p:spPr>
-                  </p:pic>
-                </p:oleObj>
-              </mc:Fallback>
-            </mc:AlternateContent>
-          </a:graphicData>
-        </a:graphic>
-      </p:graphicFrame>
       <p:sp>
         <p:nvSpPr>
           <p:cNvPr id="7173" name="Text Box 4"/>
@@ -19372,101 +18921,6 @@
           </a:p>
         </p:txBody>
       </p:sp>
-      <p:graphicFrame>
-        <p:nvGraphicFramePr>
-          <p:cNvPr id="32772" name="Object 8"/>
-          <p:cNvGraphicFramePr>
-            <a:graphicFrameLocks noGrp="1" noChangeAspect="1"/>
-          </p:cNvGraphicFramePr>
-          <p:nvPr>
-            <p:ph sz="half" idx="2"/>
-          </p:nvPr>
-        </p:nvGraphicFramePr>
-        <p:xfrm>
-          <a:off x="3613150" y="4038601"/>
-          <a:ext cx="4984750" cy="835025"/>
-        </p:xfrm>
-        <a:graphic>
-          <a:graphicData uri="http://schemas.openxmlformats.org/presentationml/2006/ole">
-            <mc:AlternateContent xmlns:mc="http://schemas.openxmlformats.org/markup-compatibility/2006">
-              <mc:Choice xmlns:v="urn:schemas-microsoft-com:vml" Requires="v">
-                <p:oleObj name="Equation" r:id="rId5" imgW="2501900" imgH="419100" progId="Equation.DSMT4">
-                  <p:embed/>
-                </p:oleObj>
-              </mc:Choice>
-              <mc:Fallback>
-                <p:oleObj name="Equation" r:id="rId5" imgW="2501900" imgH="419100" progId="Equation.DSMT4">
-                  <p:embed/>
-                  <p:pic>
-                    <p:nvPicPr>
-                      <p:cNvPr id="0" name=""/>
-                      <p:cNvPicPr>
-                        <a:picLocks noChangeAspect="1" noChangeArrowheads="1"/>
-                      </p:cNvPicPr>
-                      <p:nvPr/>
-                    </p:nvPicPr>
-                    <p:blipFill>
-                      <a:blip r:embed="rId6">
-                        <a:extLst>
-                          <a:ext uri="{28A0092B-C50C-407E-A947-70E740481C1C}">
-                            <a14:useLocalDpi xmlns:a14="http://schemas.microsoft.com/office/drawing/2010/main" val="0"/>
-                          </a:ext>
-                        </a:extLst>
-                      </a:blip>
-                      <a:srcRect/>
-                      <a:stretch>
-                        <a:fillRect/>
-                      </a:stretch>
-                    </p:blipFill>
-                    <p:spPr bwMode="auto">
-                      <a:xfrm>
-                        <a:off x="3613150" y="4038601"/>
-                        <a:ext cx="4984750" cy="835025"/>
-                      </a:xfrm>
-                      <a:prstGeom prst="rect">
-                        <a:avLst/>
-                      </a:prstGeom>
-                      <a:noFill/>
-                      <a:ln>
-                        <a:noFill/>
-                      </a:ln>
-                      <a:effectLst/>
-                      <a:extLst>
-                        <a:ext uri="{909E8E84-426E-40DD-AFC4-6F175D3DCCD1}">
-                          <a14:hiddenFill xmlns:a14="http://schemas.microsoft.com/office/drawing/2010/main">
-                            <a:solidFill>
-                              <a:srgbClr val="FFFFFF"/>
-                            </a:solidFill>
-                          </a14:hiddenFill>
-                        </a:ext>
-                        <a:ext uri="{91240B29-F687-4F45-9708-019B960494DF}">
-                          <a14:hiddenLine xmlns:a14="http://schemas.microsoft.com/office/drawing/2010/main" w="9525">
-                            <a:solidFill>
-                              <a:srgbClr val="000000"/>
-                            </a:solidFill>
-                            <a:miter lim="800000"/>
-                            <a:headEnd/>
-                            <a:tailEnd/>
-                          </a14:hiddenLine>
-                        </a:ext>
-                        <a:ext uri="{AF507438-7753-43E0-B8FC-AC1667EBCBE1}">
-                          <a14:hiddenEffects xmlns:a14="http://schemas.microsoft.com/office/drawing/2010/main">
-                            <a:effectLst>
-                              <a:outerShdw dist="35921" dir="2700000" algn="ctr" rotWithShape="0">
-                                <a:srgbClr val="808080"/>
-                              </a:outerShdw>
-                            </a:effectLst>
-                          </a14:hiddenEffects>
-                        </a:ext>
-                      </a:extLst>
-                    </p:spPr>
-                  </p:pic>
-                </p:oleObj>
-              </mc:Fallback>
-            </mc:AlternateContent>
-          </a:graphicData>
-        </a:graphic>
-      </p:graphicFrame>
       <p:sp>
         <p:nvSpPr>
           <p:cNvPr id="7175" name="Slide Number Placeholder 1"/>
@@ -19818,99 +19272,6 @@
           </a:p>
         </p:txBody>
       </p:sp>
-      <p:graphicFrame>
-        <p:nvGraphicFramePr>
-          <p:cNvPr id="32775" name="Object 5"/>
-          <p:cNvGraphicFramePr>
-            <a:graphicFrameLocks noChangeAspect="1"/>
-          </p:cNvGraphicFramePr>
-          <p:nvPr/>
-        </p:nvGraphicFramePr>
-        <p:xfrm>
-          <a:off x="2362200" y="5659438"/>
-          <a:ext cx="5816600" cy="965200"/>
-        </p:xfrm>
-        <a:graphic>
-          <a:graphicData uri="http://schemas.openxmlformats.org/presentationml/2006/ole">
-            <mc:AlternateContent xmlns:mc="http://schemas.openxmlformats.org/markup-compatibility/2006">
-              <mc:Choice xmlns:v="urn:schemas-microsoft-com:vml" Requires="v">
-                <p:oleObj name="Equation" r:id="rId7" imgW="2908300" imgH="482600" progId="Equation.DSMT4">
-                  <p:embed/>
-                </p:oleObj>
-              </mc:Choice>
-              <mc:Fallback>
-                <p:oleObj name="Equation" r:id="rId7" imgW="2908300" imgH="482600" progId="Equation.DSMT4">
-                  <p:embed/>
-                  <p:pic>
-                    <p:nvPicPr>
-                      <p:cNvPr id="0" name=""/>
-                      <p:cNvPicPr>
-                        <a:picLocks noChangeAspect="1" noChangeArrowheads="1"/>
-                      </p:cNvPicPr>
-                      <p:nvPr/>
-                    </p:nvPicPr>
-                    <p:blipFill>
-                      <a:blip r:embed="rId8">
-                        <a:extLst>
-                          <a:ext uri="{28A0092B-C50C-407E-A947-70E740481C1C}">
-                            <a14:useLocalDpi xmlns:a14="http://schemas.microsoft.com/office/drawing/2010/main" val="0"/>
-                          </a:ext>
-                        </a:extLst>
-                      </a:blip>
-                      <a:srcRect/>
-                      <a:stretch>
-                        <a:fillRect/>
-                      </a:stretch>
-                    </p:blipFill>
-                    <p:spPr bwMode="auto">
-                      <a:xfrm>
-                        <a:off x="2362200" y="5659438"/>
-                        <a:ext cx="5816600" cy="965200"/>
-                      </a:xfrm>
-                      <a:prstGeom prst="rect">
-                        <a:avLst/>
-                      </a:prstGeom>
-                      <a:noFill/>
-                      <a:ln>
-                        <a:noFill/>
-                      </a:ln>
-                      <a:effectLst/>
-                      <a:extLst>
-                        <a:ext uri="{909E8E84-426E-40DD-AFC4-6F175D3DCCD1}">
-                          <a14:hiddenFill xmlns:a14="http://schemas.microsoft.com/office/drawing/2010/main">
-                            <a:solidFill>
-                              <a:srgbClr val="FFFFFF"/>
-                            </a:solidFill>
-                          </a14:hiddenFill>
-                        </a:ext>
-                        <a:ext uri="{91240B29-F687-4F45-9708-019B960494DF}">
-                          <a14:hiddenLine xmlns:a14="http://schemas.microsoft.com/office/drawing/2010/main" w="9525">
-                            <a:solidFill>
-                              <a:srgbClr val="000000"/>
-                            </a:solidFill>
-                            <a:miter lim="800000"/>
-                            <a:headEnd/>
-                            <a:tailEnd/>
-                          </a14:hiddenLine>
-                        </a:ext>
-                        <a:ext uri="{AF507438-7753-43E0-B8FC-AC1667EBCBE1}">
-                          <a14:hiddenEffects xmlns:a14="http://schemas.microsoft.com/office/drawing/2010/main">
-                            <a:effectLst>
-                              <a:outerShdw dist="35921" dir="2700000" algn="ctr" rotWithShape="0">
-                                <a:srgbClr val="808080"/>
-                              </a:outerShdw>
-                            </a:effectLst>
-                          </a14:hiddenEffects>
-                        </a:ext>
-                      </a:extLst>
-                    </p:spPr>
-                  </p:pic>
-                </p:oleObj>
-              </mc:Fallback>
-            </mc:AlternateContent>
-          </a:graphicData>
-        </a:graphic>
-      </p:graphicFrame>
       <p:sp>
         <p:nvSpPr>
           <p:cNvPr id="11" name="Text Box 4"/>
@@ -20090,6 +19451,315 @@
                 <a:srgbClr val="000000"/>
               </a:solidFill>
             </a:endParaRPr>
+          </a:p>
+        </p:txBody>
+      </p:sp>
+      <p:sp>
+        <p:nvSpPr>
+          <p:cNvPr id="32776" name="TextBox 32775"/>
+          <p:cNvSpPr txBox="1"/>
+          <p:nvPr/>
+        </p:nvSpPr>
+        <p:spPr>
+          <a:xfrm>
+            <a:off x="5105400" y="1752600"/>
+            <a:ext cx="3657600" cy="838200"/>
+          </a:xfrm>
+          <a:prstGeom prst="rect">
+            <a:avLst/>
+          </a:prstGeom>
+          <a:noFill/>
+        </p:spPr>
+        <p:txBody>
+          <a:bodyPr wrap="square" anchor="ctr" lIns="0" rIns="0" tIns="0" bIns="0">
+            <a:spAutoFit/>
+          </a:bodyPr>
+          <a:lstStyle/>
+          <a:p>
+            <a:r>
+              <a:rPr sz="2000">
+                <a:latin typeface="Cambria"/>
+              </a:rPr>
+              <a:t>P(x | λ) = λ</a:t>
+            </a:r>
+            <a:r>
+              <a:rPr sz="2000" baseline="30000">
+                <a:latin typeface="Cambria"/>
+              </a:rPr>
+              <a:t>x</a:t>
+            </a:r>
+            <a:r>
+              <a:rPr sz="2000">
+                <a:latin typeface="Cambria"/>
+              </a:rPr>
+              <a:t> exp(−λ) / x!</a:t>
+            </a:r>
+          </a:p>
+        </p:txBody>
+      </p:sp>
+      <p:sp>
+        <p:nvSpPr>
+          <p:cNvPr id="32777" name="TextBox 32776"/>
+          <p:cNvSpPr txBox="1"/>
+          <p:nvPr/>
+        </p:nvSpPr>
+        <p:spPr>
+          <a:xfrm>
+            <a:off x="3613150" y="4038601"/>
+            <a:ext cx="8395970" cy="835025"/>
+          </a:xfrm>
+          <a:prstGeom prst="rect">
+            <a:avLst/>
+          </a:prstGeom>
+          <a:noFill/>
+        </p:spPr>
+        <p:txBody>
+          <a:bodyPr wrap="square" anchor="ctr" lIns="0" rIns="0" tIns="0" bIns="0">
+            <a:spAutoFit/>
+          </a:bodyPr>
+          <a:lstStyle/>
+          <a:p>
+            <a:r>
+              <a:rPr sz="1800">
+                <a:latin typeface="Cambria"/>
+              </a:rPr>
+              <a:t>P(x | p, λ</a:t>
+            </a:r>
+            <a:r>
+              <a:rPr sz="1800" baseline="-25000">
+                <a:latin typeface="Cambria"/>
+              </a:rPr>
+              <a:t>1</a:t>
+            </a:r>
+            <a:r>
+              <a:rPr sz="1800">
+                <a:latin typeface="Cambria"/>
+              </a:rPr>
+              <a:t>, λ</a:t>
+            </a:r>
+            <a:r>
+              <a:rPr sz="1800" baseline="-25000">
+                <a:latin typeface="Cambria"/>
+              </a:rPr>
+              <a:t>2</a:t>
+            </a:r>
+            <a:r>
+              <a:rPr sz="1800">
+                <a:latin typeface="Cambria"/>
+              </a:rPr>
+              <a:t>) = p λ</a:t>
+            </a:r>
+            <a:r>
+              <a:rPr sz="1800" baseline="-25000">
+                <a:latin typeface="Cambria"/>
+              </a:rPr>
+              <a:t>1</a:t>
+            </a:r>
+            <a:r>
+              <a:rPr sz="1800" baseline="30000">
+                <a:latin typeface="Cambria"/>
+              </a:rPr>
+              <a:t>x</a:t>
+            </a:r>
+            <a:r>
+              <a:rPr sz="1800">
+                <a:latin typeface="Cambria"/>
+              </a:rPr>
+              <a:t> exp(−λ</a:t>
+            </a:r>
+            <a:r>
+              <a:rPr sz="1800" baseline="-25000">
+                <a:latin typeface="Cambria"/>
+              </a:rPr>
+              <a:t>1</a:t>
+            </a:r>
+            <a:r>
+              <a:rPr sz="1800">
+                <a:latin typeface="Cambria"/>
+              </a:rPr>
+              <a:t>) / x! + (1 − p) λ</a:t>
+            </a:r>
+            <a:r>
+              <a:rPr sz="1800" baseline="-25000">
+                <a:latin typeface="Cambria"/>
+              </a:rPr>
+              <a:t>2</a:t>
+            </a:r>
+            <a:r>
+              <a:rPr sz="1800" baseline="30000">
+                <a:latin typeface="Cambria"/>
+              </a:rPr>
+              <a:t>x</a:t>
+            </a:r>
+            <a:r>
+              <a:rPr sz="1800">
+                <a:latin typeface="Cambria"/>
+              </a:rPr>
+              <a:t> exp(−λ</a:t>
+            </a:r>
+            <a:r>
+              <a:rPr sz="1800" baseline="-25000">
+                <a:latin typeface="Cambria"/>
+              </a:rPr>
+              <a:t>2</a:t>
+            </a:r>
+            <a:r>
+              <a:rPr sz="1800">
+                <a:latin typeface="Cambria"/>
+              </a:rPr>
+              <a:t>) / x!</a:t>
+            </a:r>
+          </a:p>
+        </p:txBody>
+      </p:sp>
+      <p:sp>
+        <p:nvSpPr>
+          <p:cNvPr id="32778" name="TextBox 32777"/>
+          <p:cNvSpPr txBox="1"/>
+          <p:nvPr/>
+        </p:nvSpPr>
+        <p:spPr>
+          <a:xfrm>
+            <a:off x="2362200" y="5659438"/>
+            <a:ext cx="9646920" cy="965200"/>
+          </a:xfrm>
+          <a:prstGeom prst="rect">
+            <a:avLst/>
+          </a:prstGeom>
+          <a:noFill/>
+        </p:spPr>
+        <p:txBody>
+          <a:bodyPr wrap="square" anchor="ctr" lIns="0" rIns="0" tIns="0" bIns="0">
+            <a:spAutoFit/>
+          </a:bodyPr>
+          <a:lstStyle/>
+          <a:p>
+            <a:r>
+              <a:rPr sz="1700">
+                <a:latin typeface="Cambria"/>
+              </a:rPr>
+              <a:t>P(x | p, λ</a:t>
+            </a:r>
+            <a:r>
+              <a:rPr sz="1700" baseline="-25000">
+                <a:latin typeface="Cambria"/>
+              </a:rPr>
+              <a:t>1</a:t>
+            </a:r>
+            <a:r>
+              <a:rPr sz="1700">
+                <a:latin typeface="Cambria"/>
+              </a:rPr>
+              <a:t>, λ</a:t>
+            </a:r>
+            <a:r>
+              <a:rPr sz="1700" baseline="-25000">
+                <a:latin typeface="Cambria"/>
+              </a:rPr>
+              <a:t>2</a:t>
+            </a:r>
+            <a:r>
+              <a:rPr sz="1700">
+                <a:latin typeface="Cambria"/>
+              </a:rPr>
+              <a:t>) = ∏</a:t>
+            </a:r>
+            <a:r>
+              <a:rPr sz="1700" baseline="-25000">
+                <a:latin typeface="Cambria"/>
+              </a:rPr>
+              <a:t>i</a:t>
+            </a:r>
+            <a:r>
+              <a:rPr sz="1700">
+                <a:latin typeface="Cambria"/>
+              </a:rPr>
+              <a:t> ( p λ</a:t>
+            </a:r>
+            <a:r>
+              <a:rPr sz="1700" baseline="-25000">
+                <a:latin typeface="Cambria"/>
+              </a:rPr>
+              <a:t>1</a:t>
+            </a:r>
+            <a:r>
+              <a:rPr sz="1700" baseline="30000">
+                <a:latin typeface="Cambria"/>
+              </a:rPr>
+              <a:t>xᵢ</a:t>
+            </a:r>
+            <a:r>
+              <a:rPr sz="1700">
+                <a:latin typeface="Cambria"/>
+              </a:rPr>
+              <a:t> exp(−λ</a:t>
+            </a:r>
+            <a:r>
+              <a:rPr sz="1700" baseline="-25000">
+                <a:latin typeface="Cambria"/>
+              </a:rPr>
+              <a:t>1</a:t>
+            </a:r>
+            <a:r>
+              <a:rPr sz="1700">
+                <a:latin typeface="Cambria"/>
+              </a:rPr>
+              <a:t>) / x</a:t>
+            </a:r>
+            <a:r>
+              <a:rPr sz="1700" baseline="-25000">
+                <a:latin typeface="Cambria"/>
+              </a:rPr>
+              <a:t>i</a:t>
+            </a:r>
+            <a:r>
+              <a:rPr sz="1700">
+                <a:latin typeface="Cambria"/>
+              </a:rPr>
+              <a:t>! + (1 − p) λ</a:t>
+            </a:r>
+            <a:r>
+              <a:rPr sz="1700" baseline="-25000">
+                <a:latin typeface="Cambria"/>
+              </a:rPr>
+              <a:t>2</a:t>
+            </a:r>
+            <a:r>
+              <a:rPr sz="1700" baseline="30000">
+                <a:latin typeface="Cambria"/>
+              </a:rPr>
+              <a:t>xᵢ</a:t>
+            </a:r>
+            <a:r>
+              <a:rPr sz="1700">
+                <a:latin typeface="Cambria"/>
+              </a:rPr>
+              <a:t> exp(−λ</a:t>
+            </a:r>
+            <a:r>
+              <a:rPr sz="1700" baseline="-25000">
+                <a:latin typeface="Cambria"/>
+              </a:rPr>
+              <a:t>2</a:t>
+            </a:r>
+            <a:r>
+              <a:rPr sz="1700">
+                <a:latin typeface="Cambria"/>
+              </a:rPr>
+              <a:t>) / x</a:t>
+            </a:r>
+            <a:r>
+              <a:rPr sz="1700" baseline="-25000">
+                <a:latin typeface="Cambria"/>
+              </a:rPr>
+              <a:t>i</a:t>
+            </a:r>
+            <a:r>
+              <a:rPr sz="1700">
+                <a:latin typeface="Cambria"/>
+              </a:rPr>
+              <a:t>! )</a:t>
+            </a:r>
           </a:p>
         </p:txBody>
       </p:sp>
@@ -20482,99 +20152,6 @@
           </a:p>
         </p:txBody>
       </p:sp>
-      <p:graphicFrame>
-        <p:nvGraphicFramePr>
-          <p:cNvPr id="34819" name="Object 5"/>
-          <p:cNvGraphicFramePr>
-            <a:graphicFrameLocks noChangeAspect="1"/>
-          </p:cNvGraphicFramePr>
-          <p:nvPr/>
-        </p:nvGraphicFramePr>
-        <p:xfrm>
-          <a:off x="2667000" y="2090738"/>
-          <a:ext cx="5816600" cy="965200"/>
-        </p:xfrm>
-        <a:graphic>
-          <a:graphicData uri="http://schemas.openxmlformats.org/presentationml/2006/ole">
-            <mc:AlternateContent xmlns:mc="http://schemas.openxmlformats.org/markup-compatibility/2006">
-              <mc:Choice xmlns:v="urn:schemas-microsoft-com:vml" Requires="v">
-                <p:oleObj name="Equation" r:id="rId3" imgW="2908300" imgH="482600" progId="Equation.DSMT4">
-                  <p:embed/>
-                </p:oleObj>
-              </mc:Choice>
-              <mc:Fallback>
-                <p:oleObj name="Equation" r:id="rId3" imgW="2908300" imgH="482600" progId="Equation.DSMT4">
-                  <p:embed/>
-                  <p:pic>
-                    <p:nvPicPr>
-                      <p:cNvPr id="0" name=""/>
-                      <p:cNvPicPr>
-                        <a:picLocks noChangeAspect="1" noChangeArrowheads="1"/>
-                      </p:cNvPicPr>
-                      <p:nvPr/>
-                    </p:nvPicPr>
-                    <p:blipFill>
-                      <a:blip r:embed="rId4">
-                        <a:extLst>
-                          <a:ext uri="{28A0092B-C50C-407E-A947-70E740481C1C}">
-                            <a14:useLocalDpi xmlns:a14="http://schemas.microsoft.com/office/drawing/2010/main" val="0"/>
-                          </a:ext>
-                        </a:extLst>
-                      </a:blip>
-                      <a:srcRect/>
-                      <a:stretch>
-                        <a:fillRect/>
-                      </a:stretch>
-                    </p:blipFill>
-                    <p:spPr bwMode="auto">
-                      <a:xfrm>
-                        <a:off x="2667000" y="2090738"/>
-                        <a:ext cx="5816600" cy="965200"/>
-                      </a:xfrm>
-                      <a:prstGeom prst="rect">
-                        <a:avLst/>
-                      </a:prstGeom>
-                      <a:noFill/>
-                      <a:ln>
-                        <a:noFill/>
-                      </a:ln>
-                      <a:effectLst/>
-                      <a:extLst>
-                        <a:ext uri="{909E8E84-426E-40DD-AFC4-6F175D3DCCD1}">
-                          <a14:hiddenFill xmlns:a14="http://schemas.microsoft.com/office/drawing/2010/main">
-                            <a:solidFill>
-                              <a:srgbClr val="FFFFFF"/>
-                            </a:solidFill>
-                          </a14:hiddenFill>
-                        </a:ext>
-                        <a:ext uri="{91240B29-F687-4F45-9708-019B960494DF}">
-                          <a14:hiddenLine xmlns:a14="http://schemas.microsoft.com/office/drawing/2010/main" w="9525">
-                            <a:solidFill>
-                              <a:srgbClr val="000000"/>
-                            </a:solidFill>
-                            <a:miter lim="800000"/>
-                            <a:headEnd/>
-                            <a:tailEnd/>
-                          </a14:hiddenLine>
-                        </a:ext>
-                        <a:ext uri="{AF507438-7753-43E0-B8FC-AC1667EBCBE1}">
-                          <a14:hiddenEffects xmlns:a14="http://schemas.microsoft.com/office/drawing/2010/main">
-                            <a:effectLst>
-                              <a:outerShdw dist="35921" dir="2700000" algn="ctr" rotWithShape="0">
-                                <a:srgbClr val="808080"/>
-                              </a:outerShdw>
-                            </a:effectLst>
-                          </a14:hiddenEffects>
-                        </a:ext>
-                      </a:extLst>
-                    </p:spPr>
-                  </p:pic>
-                </p:oleObj>
-              </mc:Fallback>
-            </mc:AlternateContent>
-          </a:graphicData>
-        </a:graphic>
-      </p:graphicFrame>
       <p:sp>
         <p:nvSpPr>
           <p:cNvPr id="11" name="Text Box 4"/>
@@ -20930,6 +20507,157 @@
                 </a:solidFill>
               </a:rPr>
               <a:t>are we solving for here with optimization?</a:t>
+            </a:r>
+          </a:p>
+        </p:txBody>
+      </p:sp>
+      <p:sp>
+        <p:nvSpPr>
+          <p:cNvPr id="7176" name="TextBox 7175"/>
+          <p:cNvSpPr txBox="1"/>
+          <p:nvPr/>
+        </p:nvSpPr>
+        <p:spPr>
+          <a:xfrm>
+            <a:off x="2667000" y="2090738"/>
+            <a:ext cx="9342120" cy="965200"/>
+          </a:xfrm>
+          <a:prstGeom prst="rect">
+            <a:avLst/>
+          </a:prstGeom>
+          <a:noFill/>
+        </p:spPr>
+        <p:txBody>
+          <a:bodyPr wrap="square" anchor="ctr" lIns="0" rIns="0" tIns="0" bIns="0">
+            <a:spAutoFit/>
+          </a:bodyPr>
+          <a:lstStyle/>
+          <a:p>
+            <a:r>
+              <a:rPr sz="1700">
+                <a:latin typeface="Cambria"/>
+              </a:rPr>
+              <a:t>P(x | p, λ</a:t>
+            </a:r>
+            <a:r>
+              <a:rPr sz="1700" baseline="-25000">
+                <a:latin typeface="Cambria"/>
+              </a:rPr>
+              <a:t>1</a:t>
+            </a:r>
+            <a:r>
+              <a:rPr sz="1700">
+                <a:latin typeface="Cambria"/>
+              </a:rPr>
+              <a:t>, λ</a:t>
+            </a:r>
+            <a:r>
+              <a:rPr sz="1700" baseline="-25000">
+                <a:latin typeface="Cambria"/>
+              </a:rPr>
+              <a:t>2</a:t>
+            </a:r>
+            <a:r>
+              <a:rPr sz="1700">
+                <a:latin typeface="Cambria"/>
+              </a:rPr>
+              <a:t>) = ∏</a:t>
+            </a:r>
+            <a:r>
+              <a:rPr sz="1700" baseline="-25000">
+                <a:latin typeface="Cambria"/>
+              </a:rPr>
+              <a:t>i</a:t>
+            </a:r>
+            <a:r>
+              <a:rPr sz="1700">
+                <a:latin typeface="Cambria"/>
+              </a:rPr>
+              <a:t> ( p λ</a:t>
+            </a:r>
+            <a:r>
+              <a:rPr sz="1700" baseline="-25000">
+                <a:latin typeface="Cambria"/>
+              </a:rPr>
+              <a:t>1</a:t>
+            </a:r>
+            <a:r>
+              <a:rPr sz="1700" baseline="30000">
+                <a:latin typeface="Cambria"/>
+              </a:rPr>
+              <a:t>xᵢ</a:t>
+            </a:r>
+            <a:r>
+              <a:rPr sz="1700">
+                <a:latin typeface="Cambria"/>
+              </a:rPr>
+              <a:t> exp(−λ</a:t>
+            </a:r>
+            <a:r>
+              <a:rPr sz="1700" baseline="-25000">
+                <a:latin typeface="Cambria"/>
+              </a:rPr>
+              <a:t>1</a:t>
+            </a:r>
+            <a:r>
+              <a:rPr sz="1700">
+                <a:latin typeface="Cambria"/>
+              </a:rPr>
+              <a:t>) / x</a:t>
+            </a:r>
+            <a:r>
+              <a:rPr sz="1700" baseline="-25000">
+                <a:latin typeface="Cambria"/>
+              </a:rPr>
+              <a:t>i</a:t>
+            </a:r>
+            <a:r>
+              <a:rPr sz="1700">
+                <a:latin typeface="Cambria"/>
+              </a:rPr>
+              <a:t>! + (1 − p) λ</a:t>
+            </a:r>
+            <a:r>
+              <a:rPr sz="1700" baseline="-25000">
+                <a:latin typeface="Cambria"/>
+              </a:rPr>
+              <a:t>2</a:t>
+            </a:r>
+            <a:r>
+              <a:rPr sz="1700" baseline="30000">
+                <a:latin typeface="Cambria"/>
+              </a:rPr>
+              <a:t>xᵢ</a:t>
+            </a:r>
+            <a:r>
+              <a:rPr sz="1700">
+                <a:latin typeface="Cambria"/>
+              </a:rPr>
+              <a:t> exp(−λ</a:t>
+            </a:r>
+            <a:r>
+              <a:rPr sz="1700" baseline="-25000">
+                <a:latin typeface="Cambria"/>
+              </a:rPr>
+              <a:t>2</a:t>
+            </a:r>
+            <a:r>
+              <a:rPr sz="1700">
+                <a:latin typeface="Cambria"/>
+              </a:rPr>
+              <a:t>) / x</a:t>
+            </a:r>
+            <a:r>
+              <a:rPr sz="1700" baseline="-25000">
+                <a:latin typeface="Cambria"/>
+              </a:rPr>
+              <a:t>i</a:t>
+            </a:r>
+            <a:r>
+              <a:rPr sz="1700">
+                <a:latin typeface="Cambria"/>
+              </a:rPr>
+              <a:t>! )</a:t>
             </a:r>
           </a:p>
         </p:txBody>
@@ -25200,196 +24928,6 @@
           </a:p>
         </p:txBody>
       </p:sp>
-      <p:graphicFrame>
-        <p:nvGraphicFramePr>
-          <p:cNvPr id="49155" name="Object 5"/>
-          <p:cNvGraphicFramePr>
-            <a:graphicFrameLocks noGrp="1" noChangeAspect="1"/>
-          </p:cNvGraphicFramePr>
-          <p:nvPr>
-            <p:ph sz="half" idx="1"/>
-          </p:nvPr>
-        </p:nvGraphicFramePr>
-        <p:xfrm>
-          <a:off x="2692401" y="2354263"/>
-          <a:ext cx="2511425" cy="482600"/>
-        </p:xfrm>
-        <a:graphic>
-          <a:graphicData uri="http://schemas.openxmlformats.org/presentationml/2006/ole">
-            <mc:AlternateContent xmlns:mc="http://schemas.openxmlformats.org/markup-compatibility/2006">
-              <mc:Choice xmlns:v="urn:schemas-microsoft-com:vml" Requires="v">
-                <p:oleObj name="Equation" r:id="rId3" imgW="1257300" imgH="241300" progId="Equation.DSMT4">
-                  <p:embed/>
-                </p:oleObj>
-              </mc:Choice>
-              <mc:Fallback>
-                <p:oleObj name="Equation" r:id="rId3" imgW="1257300" imgH="241300" progId="Equation.DSMT4">
-                  <p:embed/>
-                  <p:pic>
-                    <p:nvPicPr>
-                      <p:cNvPr id="0" name=""/>
-                      <p:cNvPicPr>
-                        <a:picLocks noChangeAspect="1" noChangeArrowheads="1"/>
-                      </p:cNvPicPr>
-                      <p:nvPr/>
-                    </p:nvPicPr>
-                    <p:blipFill>
-                      <a:blip r:embed="rId4">
-                        <a:extLst>
-                          <a:ext uri="{28A0092B-C50C-407E-A947-70E740481C1C}">
-                            <a14:useLocalDpi xmlns:a14="http://schemas.microsoft.com/office/drawing/2010/main" val="0"/>
-                          </a:ext>
-                        </a:extLst>
-                      </a:blip>
-                      <a:srcRect/>
-                      <a:stretch>
-                        <a:fillRect/>
-                      </a:stretch>
-                    </p:blipFill>
-                    <p:spPr bwMode="auto">
-                      <a:xfrm>
-                        <a:off x="2692401" y="2354263"/>
-                        <a:ext cx="2511425" cy="482600"/>
-                      </a:xfrm>
-                      <a:prstGeom prst="rect">
-                        <a:avLst/>
-                      </a:prstGeom>
-                      <a:noFill/>
-                      <a:ln>
-                        <a:noFill/>
-                      </a:ln>
-                      <a:effectLst/>
-                      <a:extLst>
-                        <a:ext uri="{909E8E84-426E-40DD-AFC4-6F175D3DCCD1}">
-                          <a14:hiddenFill xmlns:a14="http://schemas.microsoft.com/office/drawing/2010/main">
-                            <a:solidFill>
-                              <a:srgbClr val="FFFFFF"/>
-                            </a:solidFill>
-                          </a14:hiddenFill>
-                        </a:ext>
-                        <a:ext uri="{91240B29-F687-4F45-9708-019B960494DF}">
-                          <a14:hiddenLine xmlns:a14="http://schemas.microsoft.com/office/drawing/2010/main" w="9525">
-                            <a:solidFill>
-                              <a:srgbClr val="000000"/>
-                            </a:solidFill>
-                            <a:miter lim="800000"/>
-                            <a:headEnd/>
-                            <a:tailEnd/>
-                          </a14:hiddenLine>
-                        </a:ext>
-                        <a:ext uri="{AF507438-7753-43E0-B8FC-AC1667EBCBE1}">
-                          <a14:hiddenEffects xmlns:a14="http://schemas.microsoft.com/office/drawing/2010/main">
-                            <a:effectLst>
-                              <a:outerShdw dist="35921" dir="2700000" algn="ctr" rotWithShape="0">
-                                <a:srgbClr val="808080"/>
-                              </a:outerShdw>
-                            </a:effectLst>
-                          </a14:hiddenEffects>
-                        </a:ext>
-                      </a:extLst>
-                    </p:spPr>
-                  </p:pic>
-                </p:oleObj>
-              </mc:Fallback>
-            </mc:AlternateContent>
-          </a:graphicData>
-        </a:graphic>
-      </p:graphicFrame>
-      <p:graphicFrame>
-        <p:nvGraphicFramePr>
-          <p:cNvPr id="49156" name="Object 6"/>
-          <p:cNvGraphicFramePr>
-            <a:graphicFrameLocks noGrp="1" noChangeAspect="1"/>
-          </p:cNvGraphicFramePr>
-          <p:nvPr>
-            <p:ph sz="half" idx="2"/>
-          </p:nvPr>
-        </p:nvGraphicFramePr>
-        <p:xfrm>
-          <a:off x="6780214" y="2354263"/>
-          <a:ext cx="1627187" cy="457200"/>
-        </p:xfrm>
-        <a:graphic>
-          <a:graphicData uri="http://schemas.openxmlformats.org/presentationml/2006/ole">
-            <mc:AlternateContent xmlns:mc="http://schemas.openxmlformats.org/markup-compatibility/2006">
-              <mc:Choice xmlns:v="urn:schemas-microsoft-com:vml" Requires="v">
-                <p:oleObj name="Equation" r:id="rId5" imgW="812447" imgH="228501" progId="Equation.DSMT4">
-                  <p:embed/>
-                </p:oleObj>
-              </mc:Choice>
-              <mc:Fallback>
-                <p:oleObj name="Equation" r:id="rId5" imgW="812447" imgH="228501" progId="Equation.DSMT4">
-                  <p:embed/>
-                  <p:pic>
-                    <p:nvPicPr>
-                      <p:cNvPr id="0" name=""/>
-                      <p:cNvPicPr>
-                        <a:picLocks noChangeAspect="1" noChangeArrowheads="1"/>
-                      </p:cNvPicPr>
-                      <p:nvPr/>
-                    </p:nvPicPr>
-                    <p:blipFill>
-                      <a:blip r:embed="rId6">
-                        <a:extLst>
-                          <a:ext uri="{28A0092B-C50C-407E-A947-70E740481C1C}">
-                            <a14:useLocalDpi xmlns:a14="http://schemas.microsoft.com/office/drawing/2010/main" val="0"/>
-                          </a:ext>
-                        </a:extLst>
-                      </a:blip>
-                      <a:srcRect/>
-                      <a:stretch>
-                        <a:fillRect/>
-                      </a:stretch>
-                    </p:blipFill>
-                    <p:spPr bwMode="auto">
-                      <a:xfrm>
-                        <a:off x="6780214" y="2354263"/>
-                        <a:ext cx="1627187" cy="457200"/>
-                      </a:xfrm>
-                      <a:prstGeom prst="rect">
-                        <a:avLst/>
-                      </a:prstGeom>
-                      <a:noFill/>
-                      <a:ln>
-                        <a:noFill/>
-                      </a:ln>
-                      <a:effectLst/>
-                      <a:extLst>
-                        <a:ext uri="{909E8E84-426E-40DD-AFC4-6F175D3DCCD1}">
-                          <a14:hiddenFill xmlns:a14="http://schemas.microsoft.com/office/drawing/2010/main">
-                            <a:solidFill>
-                              <a:srgbClr val="FFFFFF"/>
-                            </a:solidFill>
-                          </a14:hiddenFill>
-                        </a:ext>
-                        <a:ext uri="{91240B29-F687-4F45-9708-019B960494DF}">
-                          <a14:hiddenLine xmlns:a14="http://schemas.microsoft.com/office/drawing/2010/main" w="9525">
-                            <a:solidFill>
-                              <a:srgbClr val="000000"/>
-                            </a:solidFill>
-                            <a:miter lim="800000"/>
-                            <a:headEnd/>
-                            <a:tailEnd/>
-                          </a14:hiddenLine>
-                        </a:ext>
-                        <a:ext uri="{AF507438-7753-43E0-B8FC-AC1667EBCBE1}">
-                          <a14:hiddenEffects xmlns:a14="http://schemas.microsoft.com/office/drawing/2010/main">
-                            <a:effectLst>
-                              <a:outerShdw dist="35921" dir="2700000" algn="ctr" rotWithShape="0">
-                                <a:srgbClr val="808080"/>
-                              </a:outerShdw>
-                            </a:effectLst>
-                          </a14:hiddenEffects>
-                        </a:ext>
-                      </a:extLst>
-                    </p:spPr>
-                  </p:pic>
-                </p:oleObj>
-              </mc:Fallback>
-            </mc:AlternateContent>
-          </a:graphicData>
-        </a:graphic>
-      </p:graphicFrame>
       <p:sp>
         <p:nvSpPr>
           <p:cNvPr id="8198" name="Text Box 7"/>
@@ -25635,6 +25173,116 @@
                 <a:srgbClr val="000000"/>
               </a:solidFill>
             </a:endParaRPr>
+          </a:p>
+        </p:txBody>
+      </p:sp>
+      <p:sp>
+        <p:nvSpPr>
+          <p:cNvPr id="49157" name="TextBox 49156"/>
+          <p:cNvSpPr txBox="1"/>
+          <p:nvPr/>
+        </p:nvSpPr>
+        <p:spPr>
+          <a:xfrm>
+            <a:off x="2692401" y="2354263"/>
+            <a:ext cx="2954215" cy="482600"/>
+          </a:xfrm>
+          <a:prstGeom prst="rect">
+            <a:avLst/>
+          </a:prstGeom>
+          <a:noFill/>
+        </p:spPr>
+        <p:txBody>
+          <a:bodyPr wrap="square" anchor="ctr" lIns="0" rIns="0" tIns="0" bIns="0">
+            <a:spAutoFit/>
+          </a:bodyPr>
+          <a:lstStyle/>
+          <a:p>
+            <a:r>
+              <a:rPr sz="1900">
+                <a:latin typeface="Cambria"/>
+              </a:rPr>
+              <a:t>L</a:t>
+            </a:r>
+            <a:r>
+              <a:rPr sz="1900" baseline="-25000">
+                <a:latin typeface="Cambria"/>
+              </a:rPr>
+              <a:t>a</a:t>
+            </a:r>
+            <a:r>
+              <a:rPr sz="1900">
+                <a:latin typeface="Cambria"/>
+              </a:rPr>
+              <a:t> = ℓ</a:t>
+            </a:r>
+            <a:r>
+              <a:rPr sz="1900" baseline="-25000">
+                <a:latin typeface="Cambria"/>
+              </a:rPr>
+              <a:t>∞</a:t>
+            </a:r>
+            <a:r>
+              <a:rPr sz="1900">
+                <a:latin typeface="Cambria"/>
+              </a:rPr>
+              <a:t>(1 − e</a:t>
+            </a:r>
+            <a:r>
+              <a:rPr sz="1900" baseline="30000">
+                <a:latin typeface="Cambria"/>
+              </a:rPr>
+              <a:t>−κa</a:t>
+            </a:r>
+            <a:r>
+              <a:rPr sz="1900">
+                <a:latin typeface="Cambria"/>
+              </a:rPr>
+              <a:t>) + ε</a:t>
+            </a:r>
+          </a:p>
+        </p:txBody>
+      </p:sp>
+      <p:sp>
+        <p:nvSpPr>
+          <p:cNvPr id="49158" name="TextBox 49157"/>
+          <p:cNvSpPr txBox="1"/>
+          <p:nvPr/>
+        </p:nvSpPr>
+        <p:spPr>
+          <a:xfrm>
+            <a:off x="6780214" y="2354263"/>
+            <a:ext cx="1688123" cy="457200"/>
+          </a:xfrm>
+          <a:prstGeom prst="rect">
+            <a:avLst/>
+          </a:prstGeom>
+          <a:noFill/>
+        </p:spPr>
+        <p:txBody>
+          <a:bodyPr wrap="square" anchor="ctr" lIns="0" rIns="0" tIns="0" bIns="0">
+            <a:spAutoFit/>
+          </a:bodyPr>
+          <a:lstStyle/>
+          <a:p>
+            <a:r>
+              <a:rPr sz="1900">
+                <a:latin typeface="Cambria"/>
+              </a:rPr>
+              <a:t>ε ~ N(0, σ</a:t>
+            </a:r>
+            <a:r>
+              <a:rPr sz="1900" baseline="30000">
+                <a:latin typeface="Cambria"/>
+              </a:rPr>
+              <a:t>2</a:t>
+            </a:r>
+            <a:r>
+              <a:rPr sz="1900">
+                <a:latin typeface="Cambria"/>
+              </a:rPr>
+              <a:t>)</a:t>
+            </a:r>
           </a:p>
         </p:txBody>
       </p:sp>
@@ -25982,196 +25630,6 @@
           </a:p>
         </p:txBody>
       </p:sp>
-      <p:graphicFrame>
-        <p:nvGraphicFramePr>
-          <p:cNvPr id="51204" name="Object 5"/>
-          <p:cNvGraphicFramePr>
-            <a:graphicFrameLocks noGrp="1" noChangeAspect="1"/>
-          </p:cNvGraphicFramePr>
-          <p:nvPr>
-            <p:ph sz="half" idx="1"/>
-          </p:nvPr>
-        </p:nvGraphicFramePr>
-        <p:xfrm>
-          <a:off x="2898776" y="2298700"/>
-          <a:ext cx="2511425" cy="482600"/>
-        </p:xfrm>
-        <a:graphic>
-          <a:graphicData uri="http://schemas.openxmlformats.org/presentationml/2006/ole">
-            <mc:AlternateContent xmlns:mc="http://schemas.openxmlformats.org/markup-compatibility/2006">
-              <mc:Choice xmlns:v="urn:schemas-microsoft-com:vml" Requires="v">
-                <p:oleObj name="Equation" r:id="rId4" imgW="1257300" imgH="241300" progId="Equation.DSMT4">
-                  <p:embed/>
-                </p:oleObj>
-              </mc:Choice>
-              <mc:Fallback>
-                <p:oleObj name="Equation" r:id="rId4" imgW="1257300" imgH="241300" progId="Equation.DSMT4">
-                  <p:embed/>
-                  <p:pic>
-                    <p:nvPicPr>
-                      <p:cNvPr id="0" name=""/>
-                      <p:cNvPicPr>
-                        <a:picLocks noChangeAspect="1" noChangeArrowheads="1"/>
-                      </p:cNvPicPr>
-                      <p:nvPr/>
-                    </p:nvPicPr>
-                    <p:blipFill>
-                      <a:blip r:embed="rId5">
-                        <a:extLst>
-                          <a:ext uri="{28A0092B-C50C-407E-A947-70E740481C1C}">
-                            <a14:useLocalDpi xmlns:a14="http://schemas.microsoft.com/office/drawing/2010/main" val="0"/>
-                          </a:ext>
-                        </a:extLst>
-                      </a:blip>
-                      <a:srcRect/>
-                      <a:stretch>
-                        <a:fillRect/>
-                      </a:stretch>
-                    </p:blipFill>
-                    <p:spPr bwMode="auto">
-                      <a:xfrm>
-                        <a:off x="2898776" y="2298700"/>
-                        <a:ext cx="2511425" cy="482600"/>
-                      </a:xfrm>
-                      <a:prstGeom prst="rect">
-                        <a:avLst/>
-                      </a:prstGeom>
-                      <a:noFill/>
-                      <a:ln>
-                        <a:noFill/>
-                      </a:ln>
-                      <a:effectLst/>
-                      <a:extLst>
-                        <a:ext uri="{909E8E84-426E-40DD-AFC4-6F175D3DCCD1}">
-                          <a14:hiddenFill xmlns:a14="http://schemas.microsoft.com/office/drawing/2010/main">
-                            <a:solidFill>
-                              <a:srgbClr val="FFFFFF"/>
-                            </a:solidFill>
-                          </a14:hiddenFill>
-                        </a:ext>
-                        <a:ext uri="{91240B29-F687-4F45-9708-019B960494DF}">
-                          <a14:hiddenLine xmlns:a14="http://schemas.microsoft.com/office/drawing/2010/main" w="9525">
-                            <a:solidFill>
-                              <a:srgbClr val="000000"/>
-                            </a:solidFill>
-                            <a:miter lim="800000"/>
-                            <a:headEnd/>
-                            <a:tailEnd/>
-                          </a14:hiddenLine>
-                        </a:ext>
-                        <a:ext uri="{AF507438-7753-43E0-B8FC-AC1667EBCBE1}">
-                          <a14:hiddenEffects xmlns:a14="http://schemas.microsoft.com/office/drawing/2010/main">
-                            <a:effectLst>
-                              <a:outerShdw dist="35921" dir="2700000" algn="ctr" rotWithShape="0">
-                                <a:srgbClr val="808080"/>
-                              </a:outerShdw>
-                            </a:effectLst>
-                          </a14:hiddenEffects>
-                        </a:ext>
-                      </a:extLst>
-                    </p:spPr>
-                  </p:pic>
-                </p:oleObj>
-              </mc:Fallback>
-            </mc:AlternateContent>
-          </a:graphicData>
-        </a:graphic>
-      </p:graphicFrame>
-      <p:graphicFrame>
-        <p:nvGraphicFramePr>
-          <p:cNvPr id="51205" name="Object 6"/>
-          <p:cNvGraphicFramePr>
-            <a:graphicFrameLocks noGrp="1" noChangeAspect="1"/>
-          </p:cNvGraphicFramePr>
-          <p:nvPr>
-            <p:ph sz="half" idx="2"/>
-          </p:nvPr>
-        </p:nvGraphicFramePr>
-        <p:xfrm>
-          <a:off x="7059614" y="2298700"/>
-          <a:ext cx="1627187" cy="457200"/>
-        </p:xfrm>
-        <a:graphic>
-          <a:graphicData uri="http://schemas.openxmlformats.org/presentationml/2006/ole">
-            <mc:AlternateContent xmlns:mc="http://schemas.openxmlformats.org/markup-compatibility/2006">
-              <mc:Choice xmlns:v="urn:schemas-microsoft-com:vml" Requires="v">
-                <p:oleObj name="Equation" r:id="rId6" imgW="812447" imgH="228501" progId="Equation.DSMT4">
-                  <p:embed/>
-                </p:oleObj>
-              </mc:Choice>
-              <mc:Fallback>
-                <p:oleObj name="Equation" r:id="rId6" imgW="812447" imgH="228501" progId="Equation.DSMT4">
-                  <p:embed/>
-                  <p:pic>
-                    <p:nvPicPr>
-                      <p:cNvPr id="0" name=""/>
-                      <p:cNvPicPr>
-                        <a:picLocks noChangeAspect="1" noChangeArrowheads="1"/>
-                      </p:cNvPicPr>
-                      <p:nvPr/>
-                    </p:nvPicPr>
-                    <p:blipFill>
-                      <a:blip r:embed="rId7">
-                        <a:extLst>
-                          <a:ext uri="{28A0092B-C50C-407E-A947-70E740481C1C}">
-                            <a14:useLocalDpi xmlns:a14="http://schemas.microsoft.com/office/drawing/2010/main" val="0"/>
-                          </a:ext>
-                        </a:extLst>
-                      </a:blip>
-                      <a:srcRect/>
-                      <a:stretch>
-                        <a:fillRect/>
-                      </a:stretch>
-                    </p:blipFill>
-                    <p:spPr bwMode="auto">
-                      <a:xfrm>
-                        <a:off x="7059614" y="2298700"/>
-                        <a:ext cx="1627187" cy="457200"/>
-                      </a:xfrm>
-                      <a:prstGeom prst="rect">
-                        <a:avLst/>
-                      </a:prstGeom>
-                      <a:noFill/>
-                      <a:ln>
-                        <a:noFill/>
-                      </a:ln>
-                      <a:effectLst/>
-                      <a:extLst>
-                        <a:ext uri="{909E8E84-426E-40DD-AFC4-6F175D3DCCD1}">
-                          <a14:hiddenFill xmlns:a14="http://schemas.microsoft.com/office/drawing/2010/main">
-                            <a:solidFill>
-                              <a:srgbClr val="FFFFFF"/>
-                            </a:solidFill>
-                          </a14:hiddenFill>
-                        </a:ext>
-                        <a:ext uri="{91240B29-F687-4F45-9708-019B960494DF}">
-                          <a14:hiddenLine xmlns:a14="http://schemas.microsoft.com/office/drawing/2010/main" w="9525">
-                            <a:solidFill>
-                              <a:srgbClr val="000000"/>
-                            </a:solidFill>
-                            <a:miter lim="800000"/>
-                            <a:headEnd/>
-                            <a:tailEnd/>
-                          </a14:hiddenLine>
-                        </a:ext>
-                        <a:ext uri="{AF507438-7753-43E0-B8FC-AC1667EBCBE1}">
-                          <a14:hiddenEffects xmlns:a14="http://schemas.microsoft.com/office/drawing/2010/main">
-                            <a:effectLst>
-                              <a:outerShdw dist="35921" dir="2700000" algn="ctr" rotWithShape="0">
-                                <a:srgbClr val="808080"/>
-                              </a:outerShdw>
-                            </a:effectLst>
-                          </a14:hiddenEffects>
-                        </a:ext>
-                      </a:extLst>
-                    </p:spPr>
-                  </p:pic>
-                </p:oleObj>
-              </mc:Fallback>
-            </mc:AlternateContent>
-          </a:graphicData>
-        </a:graphic>
-      </p:graphicFrame>
       <p:sp>
         <p:nvSpPr>
           <p:cNvPr id="15367" name="Slide Number Placeholder 1"/>
@@ -26317,6 +25775,116 @@
                 <a:srgbClr val="000000"/>
               </a:solidFill>
             </a:endParaRPr>
+          </a:p>
+        </p:txBody>
+      </p:sp>
+      <p:sp>
+        <p:nvSpPr>
+          <p:cNvPr id="51206" name="TextBox 51205"/>
+          <p:cNvSpPr txBox="1"/>
+          <p:nvPr/>
+        </p:nvSpPr>
+        <p:spPr>
+          <a:xfrm>
+            <a:off x="2898776" y="2298700"/>
+            <a:ext cx="2954215" cy="482600"/>
+          </a:xfrm>
+          <a:prstGeom prst="rect">
+            <a:avLst/>
+          </a:prstGeom>
+          <a:noFill/>
+        </p:spPr>
+        <p:txBody>
+          <a:bodyPr wrap="square" anchor="ctr" lIns="0" rIns="0" tIns="0" bIns="0">
+            <a:spAutoFit/>
+          </a:bodyPr>
+          <a:lstStyle/>
+          <a:p>
+            <a:r>
+              <a:rPr sz="1900">
+                <a:latin typeface="Cambria"/>
+              </a:rPr>
+              <a:t>L</a:t>
+            </a:r>
+            <a:r>
+              <a:rPr sz="1900" baseline="-25000">
+                <a:latin typeface="Cambria"/>
+              </a:rPr>
+              <a:t>a</a:t>
+            </a:r>
+            <a:r>
+              <a:rPr sz="1900">
+                <a:latin typeface="Cambria"/>
+              </a:rPr>
+              <a:t> = ℓ</a:t>
+            </a:r>
+            <a:r>
+              <a:rPr sz="1900" baseline="-25000">
+                <a:latin typeface="Cambria"/>
+              </a:rPr>
+              <a:t>∞</a:t>
+            </a:r>
+            <a:r>
+              <a:rPr sz="1900">
+                <a:latin typeface="Cambria"/>
+              </a:rPr>
+              <a:t>(1 − e</a:t>
+            </a:r>
+            <a:r>
+              <a:rPr sz="1900" baseline="30000">
+                <a:latin typeface="Cambria"/>
+              </a:rPr>
+              <a:t>−κa</a:t>
+            </a:r>
+            <a:r>
+              <a:rPr sz="1900">
+                <a:latin typeface="Cambria"/>
+              </a:rPr>
+              <a:t>) + ε</a:t>
+            </a:r>
+          </a:p>
+        </p:txBody>
+      </p:sp>
+      <p:sp>
+        <p:nvSpPr>
+          <p:cNvPr id="51207" name="TextBox 51206"/>
+          <p:cNvSpPr txBox="1"/>
+          <p:nvPr/>
+        </p:nvSpPr>
+        <p:spPr>
+          <a:xfrm>
+            <a:off x="7059614" y="2298700"/>
+            <a:ext cx="1688123" cy="457200"/>
+          </a:xfrm>
+          <a:prstGeom prst="rect">
+            <a:avLst/>
+          </a:prstGeom>
+          <a:noFill/>
+        </p:spPr>
+        <p:txBody>
+          <a:bodyPr wrap="square" anchor="ctr" lIns="0" rIns="0" tIns="0" bIns="0">
+            <a:spAutoFit/>
+          </a:bodyPr>
+          <a:lstStyle/>
+          <a:p>
+            <a:r>
+              <a:rPr sz="1900">
+                <a:latin typeface="Cambria"/>
+              </a:rPr>
+              <a:t>ε ~ N(0, σ</a:t>
+            </a:r>
+            <a:r>
+              <a:rPr sz="1900" baseline="30000">
+                <a:latin typeface="Cambria"/>
+              </a:rPr>
+              <a:t>2</a:t>
+            </a:r>
+            <a:r>
+              <a:rPr sz="1900">
+                <a:latin typeface="Cambria"/>
+              </a:rPr>
+              <a:t>)</a:t>
+            </a:r>
           </a:p>
         </p:txBody>
       </p:sp>
@@ -26540,13 +26108,27 @@
             </a:pPr>
             <a:r>
               <a:rPr lang="en-AU" altLang="en-US" dirty="0"/>
-              <a:t>Estimate the values for    , </a:t>
+              <a:t>Estimate the values for </a:t>
             </a:r>
             <a:r>
               <a:rPr lang="en-AU" altLang="en-US" dirty="0">
-                <a:sym typeface="Symbol" charset="2"/>
+                <a:latin typeface="Cambria"/>
               </a:rPr>
-              <a:t>, and  from the age and </a:t>
+              <a:t>ℓ</a:t>
+            </a:r>
+            <a:r>
+              <a:rPr lang="en-AU" altLang="en-US" dirty="0" baseline="-25000">
+                <a:latin typeface="Cambria"/>
+              </a:rPr>
+              <a:t>∞</a:t>
+            </a:r>
+            <a:r>
+              <a:rPr lang="en-AU" altLang="en-US" dirty="0"/>
+              <a:t>, </a:t>
+            </a:r>
+            <a:r>
+              <a:rPr lang="en-AU" altLang="en-US" dirty="0"/>
+              <a:t>κ, and σ from the age and </a:t>
             </a:r>
           </a:p>
           <a:p>
@@ -26697,101 +26279,6 @@
           </a:p>
         </p:txBody>
       </p:sp>
-      <p:graphicFrame>
-        <p:nvGraphicFramePr>
-          <p:cNvPr id="53251" name="Object 5"/>
-          <p:cNvGraphicFramePr>
-            <a:graphicFrameLocks noGrp="1" noChangeAspect="1"/>
-          </p:cNvGraphicFramePr>
-          <p:nvPr>
-            <p:ph idx="1"/>
-          </p:nvPr>
-        </p:nvGraphicFramePr>
-        <p:xfrm>
-          <a:off x="5105400" y="1676400"/>
-          <a:ext cx="338138" cy="406400"/>
-        </p:xfrm>
-        <a:graphic>
-          <a:graphicData uri="http://schemas.openxmlformats.org/presentationml/2006/ole">
-            <mc:AlternateContent xmlns:mc="http://schemas.openxmlformats.org/markup-compatibility/2006">
-              <mc:Choice xmlns:v="urn:schemas-microsoft-com:vml" Requires="v">
-                <p:oleObj name="Equation" r:id="rId3" imgW="190500" imgH="228600" progId="Equation.DSMT4">
-                  <p:embed/>
-                </p:oleObj>
-              </mc:Choice>
-              <mc:Fallback>
-                <p:oleObj name="Equation" r:id="rId3" imgW="190500" imgH="228600" progId="Equation.DSMT4">
-                  <p:embed/>
-                  <p:pic>
-                    <p:nvPicPr>
-                      <p:cNvPr id="0" name=""/>
-                      <p:cNvPicPr>
-                        <a:picLocks noChangeAspect="1" noChangeArrowheads="1"/>
-                      </p:cNvPicPr>
-                      <p:nvPr/>
-                    </p:nvPicPr>
-                    <p:blipFill>
-                      <a:blip r:embed="rId4">
-                        <a:extLst>
-                          <a:ext uri="{28A0092B-C50C-407E-A947-70E740481C1C}">
-                            <a14:useLocalDpi xmlns:a14="http://schemas.microsoft.com/office/drawing/2010/main" val="0"/>
-                          </a:ext>
-                        </a:extLst>
-                      </a:blip>
-                      <a:srcRect/>
-                      <a:stretch>
-                        <a:fillRect/>
-                      </a:stretch>
-                    </p:blipFill>
-                    <p:spPr bwMode="auto">
-                      <a:xfrm>
-                        <a:off x="5105400" y="1676400"/>
-                        <a:ext cx="338138" cy="406400"/>
-                      </a:xfrm>
-                      <a:prstGeom prst="rect">
-                        <a:avLst/>
-                      </a:prstGeom>
-                      <a:noFill/>
-                      <a:ln>
-                        <a:noFill/>
-                      </a:ln>
-                      <a:effectLst/>
-                      <a:extLst>
-                        <a:ext uri="{909E8E84-426E-40DD-AFC4-6F175D3DCCD1}">
-                          <a14:hiddenFill xmlns:a14="http://schemas.microsoft.com/office/drawing/2010/main">
-                            <a:solidFill>
-                              <a:srgbClr val="FFFFFF"/>
-                            </a:solidFill>
-                          </a14:hiddenFill>
-                        </a:ext>
-                        <a:ext uri="{91240B29-F687-4F45-9708-019B960494DF}">
-                          <a14:hiddenLine xmlns:a14="http://schemas.microsoft.com/office/drawing/2010/main" w="9525">
-                            <a:solidFill>
-                              <a:srgbClr val="000000"/>
-                            </a:solidFill>
-                            <a:miter lim="800000"/>
-                            <a:headEnd/>
-                            <a:tailEnd/>
-                          </a14:hiddenLine>
-                        </a:ext>
-                        <a:ext uri="{AF507438-7753-43E0-B8FC-AC1667EBCBE1}">
-                          <a14:hiddenEffects xmlns:a14="http://schemas.microsoft.com/office/drawing/2010/main">
-                            <a:effectLst>
-                              <a:outerShdw dist="35921" dir="2700000" algn="ctr" rotWithShape="0">
-                                <a:srgbClr val="808080"/>
-                              </a:outerShdw>
-                            </a:effectLst>
-                          </a14:hiddenEffects>
-                        </a:ext>
-                      </a:extLst>
-                    </p:spPr>
-                  </p:pic>
-                </p:oleObj>
-              </mc:Fallback>
-            </mc:AlternateContent>
-          </a:graphicData>
-        </a:graphic>
-      </p:graphicFrame>
       <p:sp>
         <p:nvSpPr>
           <p:cNvPr id="12293" name="Slide Number Placeholder 1"/>
@@ -27989,9 +27476,8 @@
                 <a:solidFill>
                   <a:schemeClr val="hlink"/>
                 </a:solidFill>
-                <a:sym typeface="Symbol" charset="2"/>
               </a:rPr>
-              <a:t></a:t>
+              <a:t>•</a:t>
             </a:r>
           </a:p>
         </p:txBody>
@@ -28159,9 +27645,8 @@
                 <a:solidFill>
                   <a:schemeClr val="hlink"/>
                 </a:solidFill>
-                <a:sym typeface="Symbol" charset="2"/>
               </a:rPr>
-              <a:t></a:t>
+              <a:t>•</a:t>
             </a:r>
           </a:p>
         </p:txBody>
@@ -28329,9 +27814,8 @@
                 <a:solidFill>
                   <a:schemeClr val="hlink"/>
                 </a:solidFill>
-                <a:sym typeface="Symbol" charset="2"/>
               </a:rPr>
-              <a:t></a:t>
+              <a:t>•</a:t>
             </a:r>
           </a:p>
         </p:txBody>
@@ -28499,9 +27983,8 @@
                 <a:solidFill>
                   <a:schemeClr val="hlink"/>
                 </a:solidFill>
-                <a:sym typeface="Symbol" charset="2"/>
               </a:rPr>
-              <a:t></a:t>
+              <a:t>•</a:t>
             </a:r>
           </a:p>
         </p:txBody>
@@ -28669,9 +28152,8 @@
                 <a:solidFill>
                   <a:schemeClr val="hlink"/>
                 </a:solidFill>
-                <a:sym typeface="Symbol" charset="2"/>
               </a:rPr>
-              <a:t></a:t>
+              <a:t>•</a:t>
             </a:r>
           </a:p>
         </p:txBody>
@@ -28839,9 +28321,8 @@
                 <a:solidFill>
                   <a:schemeClr val="hlink"/>
                 </a:solidFill>
-                <a:sym typeface="Symbol" charset="2"/>
               </a:rPr>
-              <a:t></a:t>
+              <a:t>•</a:t>
             </a:r>
           </a:p>
         </p:txBody>
@@ -29009,9 +28490,8 @@
                 <a:solidFill>
                   <a:schemeClr val="hlink"/>
                 </a:solidFill>
-                <a:sym typeface="Symbol" charset="2"/>
               </a:rPr>
-              <a:t></a:t>
+              <a:t>•</a:t>
             </a:r>
           </a:p>
         </p:txBody>
@@ -31784,106 +31264,6 @@
           </a:p>
         </p:txBody>
       </p:sp>
-      <p:graphicFrame>
-        <p:nvGraphicFramePr>
-          <p:cNvPr id="304130" name="Object 5"/>
-          <p:cNvGraphicFramePr>
-            <a:graphicFrameLocks noGrp="1" noChangeAspect="1"/>
-          </p:cNvGraphicFramePr>
-          <p:nvPr>
-            <p:ph sz="half" idx="1"/>
-            <p:extLst>
-              <p:ext uri="{D42A27DB-BD31-4B8C-83A1-F6EECF244321}">
-                <p14:modId xmlns:p14="http://schemas.microsoft.com/office/powerpoint/2010/main" val="3137149165"/>
-              </p:ext>
-            </p:extLst>
-          </p:nvPr>
-        </p:nvGraphicFramePr>
-        <p:xfrm>
-          <a:off x="2590800" y="2772509"/>
-          <a:ext cx="2511425" cy="482600"/>
-        </p:xfrm>
-        <a:graphic>
-          <a:graphicData uri="http://schemas.openxmlformats.org/presentationml/2006/ole">
-            <mc:AlternateContent xmlns:mc="http://schemas.openxmlformats.org/markup-compatibility/2006">
-              <mc:Choice xmlns:v="urn:schemas-microsoft-com:vml" Requires="v">
-                <p:oleObj name="Equation" r:id="rId3" imgW="1257300" imgH="241300" progId="Equation.DSMT4">
-                  <p:embed/>
-                </p:oleObj>
-              </mc:Choice>
-              <mc:Fallback>
-                <p:oleObj name="Equation" r:id="rId3" imgW="1257300" imgH="241300" progId="Equation.DSMT4">
-                  <p:embed/>
-                  <p:pic>
-                    <p:nvPicPr>
-                      <p:cNvPr id="0" name=""/>
-                      <p:cNvPicPr>
-                        <a:picLocks noChangeAspect="1" noChangeArrowheads="1"/>
-                      </p:cNvPicPr>
-                      <p:nvPr/>
-                    </p:nvPicPr>
-                    <p:blipFill>
-                      <a:blip r:embed="rId4">
-                        <a:extLst>
-                          <a:ext uri="{28A0092B-C50C-407E-A947-70E740481C1C}">
-                            <a14:useLocalDpi xmlns:a14="http://schemas.microsoft.com/office/drawing/2010/main" val="0"/>
-                          </a:ext>
-                        </a:extLst>
-                      </a:blip>
-                      <a:srcRect/>
-                      <a:stretch>
-                        <a:fillRect/>
-                      </a:stretch>
-                    </p:blipFill>
-                    <p:spPr bwMode="auto">
-                      <a:xfrm>
-                        <a:off x="2590800" y="2772509"/>
-                        <a:ext cx="2511425" cy="482600"/>
-                      </a:xfrm>
-                      <a:prstGeom prst="rect">
-                        <a:avLst/>
-                      </a:prstGeom>
-                      <a:noFill/>
-                      <a:ln>
-                        <a:noFill/>
-                      </a:ln>
-                      <a:effectLst/>
-                      <a:extLst>
-                        <a:ext uri="{909E8E84-426E-40DD-AFC4-6F175D3DCCD1}">
-                          <a14:hiddenFill xmlns:a14="http://schemas.microsoft.com/office/drawing/2010/main">
-                            <a:solidFill>
-                              <a:srgbClr val="FFFFFF"/>
-                            </a:solidFill>
-                          </a14:hiddenFill>
-                        </a:ext>
-                        <a:ext uri="{91240B29-F687-4F45-9708-019B960494DF}">
-                          <a14:hiddenLine xmlns:a14="http://schemas.microsoft.com/office/drawing/2010/main" w="9525">
-                            <a:solidFill>
-                              <a:srgbClr val="000000"/>
-                            </a:solidFill>
-                            <a:miter lim="800000"/>
-                            <a:headEnd/>
-                            <a:tailEnd/>
-                          </a14:hiddenLine>
-                        </a:ext>
-                        <a:ext uri="{AF507438-7753-43E0-B8FC-AC1667EBCBE1}">
-                          <a14:hiddenEffects xmlns:a14="http://schemas.microsoft.com/office/drawing/2010/main">
-                            <a:effectLst>
-                              <a:outerShdw dist="35921" dir="2700000" algn="ctr" rotWithShape="0">
-                                <a:srgbClr val="808080"/>
-                              </a:outerShdw>
-                            </a:effectLst>
-                          </a14:hiddenEffects>
-                        </a:ext>
-                      </a:extLst>
-                    </p:spPr>
-                  </p:pic>
-                </p:oleObj>
-              </mc:Fallback>
-            </mc:AlternateContent>
-          </a:graphicData>
-        </a:graphic>
-      </p:graphicFrame>
       <p:sp>
         <p:nvSpPr>
           <p:cNvPr id="10244" name="Text Box 4"/>
@@ -32049,106 +31429,6 @@
           </a:p>
         </p:txBody>
       </p:sp>
-      <p:graphicFrame>
-        <p:nvGraphicFramePr>
-          <p:cNvPr id="304132" name="Object 7"/>
-          <p:cNvGraphicFramePr>
-            <a:graphicFrameLocks noGrp="1" noChangeAspect="1"/>
-          </p:cNvGraphicFramePr>
-          <p:nvPr>
-            <p:ph sz="half" idx="2"/>
-            <p:extLst>
-              <p:ext uri="{D42A27DB-BD31-4B8C-83A1-F6EECF244321}">
-                <p14:modId xmlns:p14="http://schemas.microsoft.com/office/powerpoint/2010/main" val="2164039034"/>
-              </p:ext>
-            </p:extLst>
-          </p:nvPr>
-        </p:nvGraphicFramePr>
-        <p:xfrm>
-          <a:off x="7162799" y="2696309"/>
-          <a:ext cx="1627188" cy="457200"/>
-        </p:xfrm>
-        <a:graphic>
-          <a:graphicData uri="http://schemas.openxmlformats.org/presentationml/2006/ole">
-            <mc:AlternateContent xmlns:mc="http://schemas.openxmlformats.org/markup-compatibility/2006">
-              <mc:Choice xmlns:v="urn:schemas-microsoft-com:vml" Requires="v">
-                <p:oleObj name="Equation" r:id="rId5" imgW="812447" imgH="228501" progId="Equation.DSMT4">
-                  <p:embed/>
-                </p:oleObj>
-              </mc:Choice>
-              <mc:Fallback>
-                <p:oleObj name="Equation" r:id="rId5" imgW="812447" imgH="228501" progId="Equation.DSMT4">
-                  <p:embed/>
-                  <p:pic>
-                    <p:nvPicPr>
-                      <p:cNvPr id="0" name=""/>
-                      <p:cNvPicPr>
-                        <a:picLocks noChangeAspect="1" noChangeArrowheads="1"/>
-                      </p:cNvPicPr>
-                      <p:nvPr/>
-                    </p:nvPicPr>
-                    <p:blipFill>
-                      <a:blip r:embed="rId6">
-                        <a:extLst>
-                          <a:ext uri="{28A0092B-C50C-407E-A947-70E740481C1C}">
-                            <a14:useLocalDpi xmlns:a14="http://schemas.microsoft.com/office/drawing/2010/main" val="0"/>
-                          </a:ext>
-                        </a:extLst>
-                      </a:blip>
-                      <a:srcRect/>
-                      <a:stretch>
-                        <a:fillRect/>
-                      </a:stretch>
-                    </p:blipFill>
-                    <p:spPr bwMode="auto">
-                      <a:xfrm>
-                        <a:off x="7162799" y="2696309"/>
-                        <a:ext cx="1627188" cy="457200"/>
-                      </a:xfrm>
-                      <a:prstGeom prst="rect">
-                        <a:avLst/>
-                      </a:prstGeom>
-                      <a:noFill/>
-                      <a:ln>
-                        <a:noFill/>
-                      </a:ln>
-                      <a:effectLst/>
-                      <a:extLst>
-                        <a:ext uri="{909E8E84-426E-40DD-AFC4-6F175D3DCCD1}">
-                          <a14:hiddenFill xmlns:a14="http://schemas.microsoft.com/office/drawing/2010/main">
-                            <a:solidFill>
-                              <a:srgbClr val="FFFFFF"/>
-                            </a:solidFill>
-                          </a14:hiddenFill>
-                        </a:ext>
-                        <a:ext uri="{91240B29-F687-4F45-9708-019B960494DF}">
-                          <a14:hiddenLine xmlns:a14="http://schemas.microsoft.com/office/drawing/2010/main" w="9525">
-                            <a:solidFill>
-                              <a:srgbClr val="000000"/>
-                            </a:solidFill>
-                            <a:miter lim="800000"/>
-                            <a:headEnd/>
-                            <a:tailEnd/>
-                          </a14:hiddenLine>
-                        </a:ext>
-                        <a:ext uri="{AF507438-7753-43E0-B8FC-AC1667EBCBE1}">
-                          <a14:hiddenEffects xmlns:a14="http://schemas.microsoft.com/office/drawing/2010/main">
-                            <a:effectLst>
-                              <a:outerShdw dist="35921" dir="2700000" algn="ctr" rotWithShape="0">
-                                <a:srgbClr val="808080"/>
-                              </a:outerShdw>
-                            </a:effectLst>
-                          </a14:hiddenEffects>
-                        </a:ext>
-                      </a:extLst>
-                    </p:spPr>
-                  </p:pic>
-                </p:oleObj>
-              </mc:Fallback>
-            </mc:AlternateContent>
-          </a:graphicData>
-        </a:graphic>
-      </p:graphicFrame>
       <p:sp>
         <p:nvSpPr>
           <p:cNvPr id="10246" name="Text Box 9"/>
@@ -33205,6 +32485,116 @@
               <a:t>of error?</a:t>
             </a:r>
             <a:endParaRPr lang="en-AU" altLang="en-US" dirty="0"/>
+          </a:p>
+        </p:txBody>
+      </p:sp>
+      <p:sp>
+        <p:nvSpPr>
+          <p:cNvPr id="304133" name="TextBox 304132"/>
+          <p:cNvSpPr txBox="1"/>
+          <p:nvPr/>
+        </p:nvSpPr>
+        <p:spPr>
+          <a:xfrm>
+            <a:off x="2590800" y="2772509"/>
+            <a:ext cx="2954215" cy="482600"/>
+          </a:xfrm>
+          <a:prstGeom prst="rect">
+            <a:avLst/>
+          </a:prstGeom>
+          <a:noFill/>
+        </p:spPr>
+        <p:txBody>
+          <a:bodyPr wrap="square" anchor="ctr" lIns="0" rIns="0" tIns="0" bIns="0">
+            <a:spAutoFit/>
+          </a:bodyPr>
+          <a:lstStyle/>
+          <a:p>
+            <a:r>
+              <a:rPr sz="1900">
+                <a:latin typeface="Cambria"/>
+              </a:rPr>
+              <a:t>L</a:t>
+            </a:r>
+            <a:r>
+              <a:rPr sz="1900" baseline="-25000">
+                <a:latin typeface="Cambria"/>
+              </a:rPr>
+              <a:t>a</a:t>
+            </a:r>
+            <a:r>
+              <a:rPr sz="1900">
+                <a:latin typeface="Cambria"/>
+              </a:rPr>
+              <a:t> = ℓ</a:t>
+            </a:r>
+            <a:r>
+              <a:rPr sz="1900" baseline="-25000">
+                <a:latin typeface="Cambria"/>
+              </a:rPr>
+              <a:t>∞</a:t>
+            </a:r>
+            <a:r>
+              <a:rPr sz="1900">
+                <a:latin typeface="Cambria"/>
+              </a:rPr>
+              <a:t>(1 − e</a:t>
+            </a:r>
+            <a:r>
+              <a:rPr sz="1900" baseline="30000">
+                <a:latin typeface="Cambria"/>
+              </a:rPr>
+              <a:t>−κa</a:t>
+            </a:r>
+            <a:r>
+              <a:rPr sz="1900">
+                <a:latin typeface="Cambria"/>
+              </a:rPr>
+              <a:t>) + ε</a:t>
+            </a:r>
+          </a:p>
+        </p:txBody>
+      </p:sp>
+      <p:sp>
+        <p:nvSpPr>
+          <p:cNvPr id="304134" name="TextBox 304133"/>
+          <p:cNvSpPr txBox="1"/>
+          <p:nvPr/>
+        </p:nvSpPr>
+        <p:spPr>
+          <a:xfrm>
+            <a:off x="7162799" y="2696309"/>
+            <a:ext cx="1688123" cy="457200"/>
+          </a:xfrm>
+          <a:prstGeom prst="rect">
+            <a:avLst/>
+          </a:prstGeom>
+          <a:noFill/>
+        </p:spPr>
+        <p:txBody>
+          <a:bodyPr wrap="square" anchor="ctr" lIns="0" rIns="0" tIns="0" bIns="0">
+            <a:spAutoFit/>
+          </a:bodyPr>
+          <a:lstStyle/>
+          <a:p>
+            <a:r>
+              <a:rPr sz="1900">
+                <a:latin typeface="Cambria"/>
+              </a:rPr>
+              <a:t>ε ~ N(0, σ</a:t>
+            </a:r>
+            <a:r>
+              <a:rPr sz="1900" baseline="30000">
+                <a:latin typeface="Cambria"/>
+              </a:rPr>
+              <a:t>2</a:t>
+            </a:r>
+            <a:r>
+              <a:rPr sz="1900">
+                <a:latin typeface="Cambria"/>
+              </a:rPr>
+              <a:t>)</a:t>
+            </a:r>
           </a:p>
         </p:txBody>
       </p:sp>
@@ -35445,106 +34835,6 @@
           </a:p>
         </p:txBody>
       </p:sp>
-      <p:graphicFrame>
-        <p:nvGraphicFramePr>
-          <p:cNvPr id="314371" name="Object 6"/>
-          <p:cNvGraphicFramePr>
-            <a:graphicFrameLocks noGrp="1" noChangeAspect="1"/>
-          </p:cNvGraphicFramePr>
-          <p:nvPr>
-            <p:ph sz="half" idx="1"/>
-            <p:extLst>
-              <p:ext uri="{D42A27DB-BD31-4B8C-83A1-F6EECF244321}">
-                <p14:modId xmlns:p14="http://schemas.microsoft.com/office/powerpoint/2010/main" val="350454184"/>
-              </p:ext>
-            </p:extLst>
-          </p:nvPr>
-        </p:nvGraphicFramePr>
-        <p:xfrm>
-          <a:off x="4572001" y="3225679"/>
-          <a:ext cx="2335213" cy="482600"/>
-        </p:xfrm>
-        <a:graphic>
-          <a:graphicData uri="http://schemas.openxmlformats.org/presentationml/2006/ole">
-            <mc:AlternateContent xmlns:mc="http://schemas.openxmlformats.org/markup-compatibility/2006">
-              <mc:Choice xmlns:v="urn:schemas-microsoft-com:vml" Requires="v">
-                <p:oleObj name="Equation" r:id="rId3" imgW="1168400" imgH="241300" progId="Equation.DSMT4">
-                  <p:embed/>
-                </p:oleObj>
-              </mc:Choice>
-              <mc:Fallback>
-                <p:oleObj name="Equation" r:id="rId3" imgW="1168400" imgH="241300" progId="Equation.DSMT4">
-                  <p:embed/>
-                  <p:pic>
-                    <p:nvPicPr>
-                      <p:cNvPr id="0" name=""/>
-                      <p:cNvPicPr>
-                        <a:picLocks noChangeAspect="1" noChangeArrowheads="1"/>
-                      </p:cNvPicPr>
-                      <p:nvPr/>
-                    </p:nvPicPr>
-                    <p:blipFill>
-                      <a:blip r:embed="rId4">
-                        <a:extLst>
-                          <a:ext uri="{28A0092B-C50C-407E-A947-70E740481C1C}">
-                            <a14:useLocalDpi xmlns:a14="http://schemas.microsoft.com/office/drawing/2010/main" val="0"/>
-                          </a:ext>
-                        </a:extLst>
-                      </a:blip>
-                      <a:srcRect/>
-                      <a:stretch>
-                        <a:fillRect/>
-                      </a:stretch>
-                    </p:blipFill>
-                    <p:spPr bwMode="auto">
-                      <a:xfrm>
-                        <a:off x="4572001" y="3225679"/>
-                        <a:ext cx="2335213" cy="482600"/>
-                      </a:xfrm>
-                      <a:prstGeom prst="rect">
-                        <a:avLst/>
-                      </a:prstGeom>
-                      <a:noFill/>
-                      <a:ln>
-                        <a:noFill/>
-                      </a:ln>
-                      <a:effectLst/>
-                      <a:extLst>
-                        <a:ext uri="{909E8E84-426E-40DD-AFC4-6F175D3DCCD1}">
-                          <a14:hiddenFill xmlns:a14="http://schemas.microsoft.com/office/drawing/2010/main">
-                            <a:solidFill>
-                              <a:srgbClr val="FFFFFF"/>
-                            </a:solidFill>
-                          </a14:hiddenFill>
-                        </a:ext>
-                        <a:ext uri="{91240B29-F687-4F45-9708-019B960494DF}">
-                          <a14:hiddenLine xmlns:a14="http://schemas.microsoft.com/office/drawing/2010/main" w="9525">
-                            <a:solidFill>
-                              <a:srgbClr val="000000"/>
-                            </a:solidFill>
-                            <a:miter lim="800000"/>
-                            <a:headEnd/>
-                            <a:tailEnd/>
-                          </a14:hiddenLine>
-                        </a:ext>
-                        <a:ext uri="{AF507438-7753-43E0-B8FC-AC1667EBCBE1}">
-                          <a14:hiddenEffects xmlns:a14="http://schemas.microsoft.com/office/drawing/2010/main">
-                            <a:effectLst>
-                              <a:outerShdw dist="35921" dir="2700000" algn="ctr" rotWithShape="0">
-                                <a:srgbClr val="808080"/>
-                              </a:outerShdw>
-                            </a:effectLst>
-                          </a14:hiddenEffects>
-                        </a:ext>
-                      </a:extLst>
-                    </p:spPr>
-                  </p:pic>
-                </p:oleObj>
-              </mc:Fallback>
-            </mc:AlternateContent>
-          </a:graphicData>
-        </a:graphic>
-      </p:graphicFrame>
       <p:sp>
         <p:nvSpPr>
           <p:cNvPr id="14341" name="Text Box 4"/>
@@ -35710,106 +35000,6 @@
           </a:p>
         </p:txBody>
       </p:sp>
-      <p:graphicFrame>
-        <p:nvGraphicFramePr>
-          <p:cNvPr id="14342" name="Object 8"/>
-          <p:cNvGraphicFramePr>
-            <a:graphicFrameLocks noGrp="1" noChangeAspect="1"/>
-          </p:cNvGraphicFramePr>
-          <p:nvPr>
-            <p:ph sz="half" idx="2"/>
-            <p:extLst>
-              <p:ext uri="{D42A27DB-BD31-4B8C-83A1-F6EECF244321}">
-                <p14:modId xmlns:p14="http://schemas.microsoft.com/office/powerpoint/2010/main" val="2580099472"/>
-              </p:ext>
-            </p:extLst>
-          </p:nvPr>
-        </p:nvGraphicFramePr>
-        <p:xfrm>
-          <a:off x="3610347" y="5045175"/>
-          <a:ext cx="2663825" cy="582612"/>
-        </p:xfrm>
-        <a:graphic>
-          <a:graphicData uri="http://schemas.openxmlformats.org/presentationml/2006/ole">
-            <mc:AlternateContent xmlns:mc="http://schemas.openxmlformats.org/markup-compatibility/2006">
-              <mc:Choice xmlns:v="urn:schemas-microsoft-com:vml" Requires="v">
-                <p:oleObj name="Equation" r:id="rId5" imgW="1333500" imgH="292100" progId="Equation.DSMT4">
-                  <p:embed/>
-                </p:oleObj>
-              </mc:Choice>
-              <mc:Fallback>
-                <p:oleObj name="Equation" r:id="rId5" imgW="1333500" imgH="292100" progId="Equation.DSMT4">
-                  <p:embed/>
-                  <p:pic>
-                    <p:nvPicPr>
-                      <p:cNvPr id="0" name=""/>
-                      <p:cNvPicPr>
-                        <a:picLocks noChangeAspect="1" noChangeArrowheads="1"/>
-                      </p:cNvPicPr>
-                      <p:nvPr/>
-                    </p:nvPicPr>
-                    <p:blipFill>
-                      <a:blip r:embed="rId6">
-                        <a:extLst>
-                          <a:ext uri="{28A0092B-C50C-407E-A947-70E740481C1C}">
-                            <a14:useLocalDpi xmlns:a14="http://schemas.microsoft.com/office/drawing/2010/main" val="0"/>
-                          </a:ext>
-                        </a:extLst>
-                      </a:blip>
-                      <a:srcRect/>
-                      <a:stretch>
-                        <a:fillRect/>
-                      </a:stretch>
-                    </p:blipFill>
-                    <p:spPr bwMode="auto">
-                      <a:xfrm>
-                        <a:off x="3610347" y="5045175"/>
-                        <a:ext cx="2663825" cy="582612"/>
-                      </a:xfrm>
-                      <a:prstGeom prst="rect">
-                        <a:avLst/>
-                      </a:prstGeom>
-                      <a:noFill/>
-                      <a:ln>
-                        <a:noFill/>
-                      </a:ln>
-                      <a:effectLst/>
-                      <a:extLst>
-                        <a:ext uri="{909E8E84-426E-40DD-AFC4-6F175D3DCCD1}">
-                          <a14:hiddenFill xmlns:a14="http://schemas.microsoft.com/office/drawing/2010/main">
-                            <a:solidFill>
-                              <a:srgbClr val="FFFFFF"/>
-                            </a:solidFill>
-                          </a14:hiddenFill>
-                        </a:ext>
-                        <a:ext uri="{91240B29-F687-4F45-9708-019B960494DF}">
-                          <a14:hiddenLine xmlns:a14="http://schemas.microsoft.com/office/drawing/2010/main" w="9525">
-                            <a:solidFill>
-                              <a:srgbClr val="000000"/>
-                            </a:solidFill>
-                            <a:miter lim="800000"/>
-                            <a:headEnd/>
-                            <a:tailEnd/>
-                          </a14:hiddenLine>
-                        </a:ext>
-                        <a:ext uri="{AF507438-7753-43E0-B8FC-AC1667EBCBE1}">
-                          <a14:hiddenEffects xmlns:a14="http://schemas.microsoft.com/office/drawing/2010/main">
-                            <a:effectLst>
-                              <a:outerShdw dist="35921" dir="2700000" algn="ctr" rotWithShape="0">
-                                <a:srgbClr val="808080"/>
-                              </a:outerShdw>
-                            </a:effectLst>
-                          </a14:hiddenEffects>
-                        </a:ext>
-                      </a:extLst>
-                    </p:spPr>
-                  </p:pic>
-                </p:oleObj>
-              </mc:Fallback>
-            </mc:AlternateContent>
-          </a:graphicData>
-        </a:graphic>
-      </p:graphicFrame>
       <p:sp>
         <p:nvSpPr>
           <p:cNvPr id="14343" name="Text Box 10"/>
@@ -36300,6 +35490,128 @@
                 <a:latin typeface="Cambria"/>
               </a:rPr>
               <a:t> )</a:t>
+            </a:r>
+          </a:p>
+        </p:txBody>
+      </p:sp>
+      <p:sp>
+        <p:nvSpPr>
+          <p:cNvPr id="314373" name="TextBox 314372"/>
+          <p:cNvSpPr txBox="1"/>
+          <p:nvPr/>
+        </p:nvSpPr>
+        <p:spPr>
+          <a:xfrm>
+            <a:off x="4572001" y="3225679"/>
+            <a:ext cx="2672861" cy="482600"/>
+          </a:xfrm>
+          <a:prstGeom prst="rect">
+            <a:avLst/>
+          </a:prstGeom>
+          <a:noFill/>
+        </p:spPr>
+        <p:txBody>
+          <a:bodyPr wrap="square" anchor="ctr" lIns="0" rIns="0" tIns="0" bIns="0">
+            <a:spAutoFit/>
+          </a:bodyPr>
+          <a:lstStyle/>
+          <a:p>
+            <a:r>
+              <a:rPr sz="1900">
+                <a:latin typeface="Cambria"/>
+              </a:rPr>
+              <a:t>L(a) = ℓ</a:t>
+            </a:r>
+            <a:r>
+              <a:rPr sz="1900" baseline="-25000">
+                <a:latin typeface="Cambria"/>
+              </a:rPr>
+              <a:t>∞</a:t>
+            </a:r>
+            <a:r>
+              <a:rPr sz="1900">
+                <a:latin typeface="Cambria"/>
+              </a:rPr>
+              <a:t>(1 − e</a:t>
+            </a:r>
+            <a:r>
+              <a:rPr sz="1900" baseline="30000">
+                <a:latin typeface="Cambria"/>
+              </a:rPr>
+              <a:t>−κa</a:t>
+            </a:r>
+            <a:r>
+              <a:rPr sz="1900">
+                <a:latin typeface="Cambria"/>
+              </a:rPr>
+              <a:t>)</a:t>
+            </a:r>
+          </a:p>
+        </p:txBody>
+      </p:sp>
+      <p:sp>
+        <p:nvSpPr>
+          <p:cNvPr id="314374" name="TextBox 314373"/>
+          <p:cNvSpPr txBox="1"/>
+          <p:nvPr/>
+        </p:nvSpPr>
+        <p:spPr>
+          <a:xfrm>
+            <a:off x="3610347" y="5045175"/>
+            <a:ext cx="6752492" cy="582612"/>
+          </a:xfrm>
+          <a:prstGeom prst="rect">
+            <a:avLst/>
+          </a:prstGeom>
+          <a:noFill/>
+        </p:spPr>
+        <p:txBody>
+          <a:bodyPr wrap="square" anchor="ctr" lIns="0" rIns="0" tIns="0" bIns="0">
+            <a:spAutoFit/>
+          </a:bodyPr>
+          <a:lstStyle/>
+          <a:p>
+            <a:r>
+              <a:rPr sz="1900">
+                <a:latin typeface="Cambria"/>
+              </a:rPr>
+              <a:t>L = 1 / (√(2π) σ) · exp( −(L(a) − L</a:t>
+            </a:r>
+            <a:r>
+              <a:rPr sz="1900" baseline="-25000">
+                <a:latin typeface="Cambria"/>
+              </a:rPr>
+              <a:t>a</a:t>
+            </a:r>
+            <a:r>
+              <a:rPr sz="1900">
+                <a:latin typeface="Cambria"/>
+              </a:rPr>
+              <a:t>)</a:t>
+            </a:r>
+            <a:r>
+              <a:rPr sz="1900" baseline="30000">
+                <a:latin typeface="Cambria"/>
+              </a:rPr>
+              <a:t>2</a:t>
+            </a:r>
+            <a:r>
+              <a:rPr sz="1900">
+                <a:latin typeface="Cambria"/>
+              </a:rPr>
+              <a:t> / (2σ</a:t>
+            </a:r>
+            <a:r>
+              <a:rPr sz="1900" baseline="30000">
+                <a:latin typeface="Cambria"/>
+              </a:rPr>
+              <a:t>2</a:t>
+            </a:r>
+            <a:r>
+              <a:rPr sz="1900">
+                <a:latin typeface="Cambria"/>
+              </a:rPr>
+              <a:t>) )</a:t>
             </a:r>
           </a:p>
         </p:txBody>
@@ -36783,101 +36095,6 @@
           </a:p>
         </p:txBody>
       </p:sp>
-      <p:graphicFrame>
-        <p:nvGraphicFramePr>
-          <p:cNvPr id="316419" name="Object 5"/>
-          <p:cNvGraphicFramePr>
-            <a:graphicFrameLocks noGrp="1" noChangeAspect="1"/>
-          </p:cNvGraphicFramePr>
-          <p:nvPr>
-            <p:ph sz="half" idx="1"/>
-          </p:nvPr>
-        </p:nvGraphicFramePr>
-        <p:xfrm>
-          <a:off x="3889376" y="1744663"/>
-          <a:ext cx="2663825" cy="584200"/>
-        </p:xfrm>
-        <a:graphic>
-          <a:graphicData uri="http://schemas.openxmlformats.org/presentationml/2006/ole">
-            <mc:AlternateContent xmlns:mc="http://schemas.openxmlformats.org/markup-compatibility/2006">
-              <mc:Choice xmlns:v="urn:schemas-microsoft-com:vml" Requires="v">
-                <p:oleObj name="Equation" r:id="rId3" imgW="1333500" imgH="292100" progId="Equation.DSMT4">
-                  <p:embed/>
-                </p:oleObj>
-              </mc:Choice>
-              <mc:Fallback>
-                <p:oleObj name="Equation" r:id="rId3" imgW="1333500" imgH="292100" progId="Equation.DSMT4">
-                  <p:embed/>
-                  <p:pic>
-                    <p:nvPicPr>
-                      <p:cNvPr id="0" name=""/>
-                      <p:cNvPicPr>
-                        <a:picLocks noChangeAspect="1" noChangeArrowheads="1"/>
-                      </p:cNvPicPr>
-                      <p:nvPr/>
-                    </p:nvPicPr>
-                    <p:blipFill>
-                      <a:blip r:embed="rId4">
-                        <a:extLst>
-                          <a:ext uri="{28A0092B-C50C-407E-A947-70E740481C1C}">
-                            <a14:useLocalDpi xmlns:a14="http://schemas.microsoft.com/office/drawing/2010/main" val="0"/>
-                          </a:ext>
-                        </a:extLst>
-                      </a:blip>
-                      <a:srcRect/>
-                      <a:stretch>
-                        <a:fillRect/>
-                      </a:stretch>
-                    </p:blipFill>
-                    <p:spPr bwMode="auto">
-                      <a:xfrm>
-                        <a:off x="3889376" y="1744663"/>
-                        <a:ext cx="2663825" cy="584200"/>
-                      </a:xfrm>
-                      <a:prstGeom prst="rect">
-                        <a:avLst/>
-                      </a:prstGeom>
-                      <a:noFill/>
-                      <a:ln>
-                        <a:noFill/>
-                      </a:ln>
-                      <a:effectLst/>
-                      <a:extLst>
-                        <a:ext uri="{909E8E84-426E-40DD-AFC4-6F175D3DCCD1}">
-                          <a14:hiddenFill xmlns:a14="http://schemas.microsoft.com/office/drawing/2010/main">
-                            <a:solidFill>
-                              <a:srgbClr val="FFFFFF"/>
-                            </a:solidFill>
-                          </a14:hiddenFill>
-                        </a:ext>
-                        <a:ext uri="{91240B29-F687-4F45-9708-019B960494DF}">
-                          <a14:hiddenLine xmlns:a14="http://schemas.microsoft.com/office/drawing/2010/main" w="9525">
-                            <a:solidFill>
-                              <a:srgbClr val="000000"/>
-                            </a:solidFill>
-                            <a:miter lim="800000"/>
-                            <a:headEnd/>
-                            <a:tailEnd/>
-                          </a14:hiddenLine>
-                        </a:ext>
-                        <a:ext uri="{AF507438-7753-43E0-B8FC-AC1667EBCBE1}">
-                          <a14:hiddenEffects xmlns:a14="http://schemas.microsoft.com/office/drawing/2010/main">
-                            <a:effectLst>
-                              <a:outerShdw dist="35921" dir="2700000" algn="ctr" rotWithShape="0">
-                                <a:srgbClr val="808080"/>
-                              </a:outerShdw>
-                            </a:effectLst>
-                          </a14:hiddenEffects>
-                        </a:ext>
-                      </a:extLst>
-                    </p:spPr>
-                  </p:pic>
-                </p:oleObj>
-              </mc:Fallback>
-            </mc:AlternateContent>
-          </a:graphicData>
-        </a:graphic>
-      </p:graphicFrame>
       <p:sp>
         <p:nvSpPr>
           <p:cNvPr id="15365" name="Text Box 4"/>
@@ -37538,101 +36755,6 @@
           </a:p>
         </p:txBody>
       </p:sp>
-      <p:graphicFrame>
-        <p:nvGraphicFramePr>
-          <p:cNvPr id="316424" name="Object 12"/>
-          <p:cNvGraphicFramePr>
-            <a:graphicFrameLocks noGrp="1" noChangeAspect="1"/>
-          </p:cNvGraphicFramePr>
-          <p:nvPr>
-            <p:ph sz="half" idx="2"/>
-          </p:nvPr>
-        </p:nvGraphicFramePr>
-        <p:xfrm>
-          <a:off x="3965575" y="3954463"/>
-          <a:ext cx="3119438" cy="741362"/>
-        </p:xfrm>
-        <a:graphic>
-          <a:graphicData uri="http://schemas.openxmlformats.org/presentationml/2006/ole">
-            <mc:AlternateContent xmlns:mc="http://schemas.openxmlformats.org/markup-compatibility/2006">
-              <mc:Choice xmlns:v="urn:schemas-microsoft-com:vml" Requires="v">
-                <p:oleObj name="Equation" r:id="rId5" imgW="1549400" imgH="368300" progId="Equation.DSMT4">
-                  <p:embed/>
-                </p:oleObj>
-              </mc:Choice>
-              <mc:Fallback>
-                <p:oleObj name="Equation" r:id="rId5" imgW="1549400" imgH="368300" progId="Equation.DSMT4">
-                  <p:embed/>
-                  <p:pic>
-                    <p:nvPicPr>
-                      <p:cNvPr id="0" name=""/>
-                      <p:cNvPicPr>
-                        <a:picLocks noChangeAspect="1" noChangeArrowheads="1"/>
-                      </p:cNvPicPr>
-                      <p:nvPr/>
-                    </p:nvPicPr>
-                    <p:blipFill>
-                      <a:blip r:embed="rId6">
-                        <a:extLst>
-                          <a:ext uri="{28A0092B-C50C-407E-A947-70E740481C1C}">
-                            <a14:useLocalDpi xmlns:a14="http://schemas.microsoft.com/office/drawing/2010/main" val="0"/>
-                          </a:ext>
-                        </a:extLst>
-                      </a:blip>
-                      <a:srcRect/>
-                      <a:stretch>
-                        <a:fillRect/>
-                      </a:stretch>
-                    </p:blipFill>
-                    <p:spPr bwMode="auto">
-                      <a:xfrm>
-                        <a:off x="3965575" y="3954463"/>
-                        <a:ext cx="3119438" cy="741362"/>
-                      </a:xfrm>
-                      <a:prstGeom prst="rect">
-                        <a:avLst/>
-                      </a:prstGeom>
-                      <a:noFill/>
-                      <a:ln>
-                        <a:noFill/>
-                      </a:ln>
-                      <a:effectLst/>
-                      <a:extLst>
-                        <a:ext uri="{909E8E84-426E-40DD-AFC4-6F175D3DCCD1}">
-                          <a14:hiddenFill xmlns:a14="http://schemas.microsoft.com/office/drawing/2010/main">
-                            <a:solidFill>
-                              <a:srgbClr val="FFFFFF"/>
-                            </a:solidFill>
-                          </a14:hiddenFill>
-                        </a:ext>
-                        <a:ext uri="{91240B29-F687-4F45-9708-019B960494DF}">
-                          <a14:hiddenLine xmlns:a14="http://schemas.microsoft.com/office/drawing/2010/main" w="9525">
-                            <a:solidFill>
-                              <a:srgbClr val="000000"/>
-                            </a:solidFill>
-                            <a:miter lim="800000"/>
-                            <a:headEnd/>
-                            <a:tailEnd/>
-                          </a14:hiddenLine>
-                        </a:ext>
-                        <a:ext uri="{AF507438-7753-43E0-B8FC-AC1667EBCBE1}">
-                          <a14:hiddenEffects xmlns:a14="http://schemas.microsoft.com/office/drawing/2010/main">
-                            <a:effectLst>
-                              <a:outerShdw dist="35921" dir="2700000" algn="ctr" rotWithShape="0">
-                                <a:srgbClr val="808080"/>
-                              </a:outerShdw>
-                            </a:effectLst>
-                          </a14:hiddenEffects>
-                        </a:ext>
-                      </a:extLst>
-                    </p:spPr>
-                  </p:pic>
-                </p:oleObj>
-              </mc:Fallback>
-            </mc:AlternateContent>
-          </a:graphicData>
-        </a:graphic>
-      </p:graphicFrame>
       <p:sp>
         <p:nvSpPr>
           <p:cNvPr id="15370" name="Text Box 14"/>
@@ -37928,6 +37050,152 @@
               <a:t>. </a:t>
             </a:r>
             <a:endParaRPr lang="en-US" sz="2000" dirty="0"/>
+          </a:p>
+        </p:txBody>
+      </p:sp>
+      <p:sp>
+        <p:nvSpPr>
+          <p:cNvPr id="316425" name="TextBox 316424"/>
+          <p:cNvSpPr txBox="1"/>
+          <p:nvPr/>
+        </p:nvSpPr>
+        <p:spPr>
+          <a:xfrm>
+            <a:off x="3889376" y="1744663"/>
+            <a:ext cx="6752492" cy="584200"/>
+          </a:xfrm>
+          <a:prstGeom prst="rect">
+            <a:avLst/>
+          </a:prstGeom>
+          <a:noFill/>
+        </p:spPr>
+        <p:txBody>
+          <a:bodyPr wrap="square" anchor="ctr" lIns="0" rIns="0" tIns="0" bIns="0">
+            <a:spAutoFit/>
+          </a:bodyPr>
+          <a:lstStyle/>
+          <a:p>
+            <a:r>
+              <a:rPr sz="1900">
+                <a:latin typeface="Cambria"/>
+              </a:rPr>
+              <a:t>L = 1 / (√(2π) σ) · exp( −(L(a) − L</a:t>
+            </a:r>
+            <a:r>
+              <a:rPr sz="1900" baseline="-25000">
+                <a:latin typeface="Cambria"/>
+              </a:rPr>
+              <a:t>a</a:t>
+            </a:r>
+            <a:r>
+              <a:rPr sz="1900">
+                <a:latin typeface="Cambria"/>
+              </a:rPr>
+              <a:t>)</a:t>
+            </a:r>
+            <a:r>
+              <a:rPr sz="1900" baseline="30000">
+                <a:latin typeface="Cambria"/>
+              </a:rPr>
+              <a:t>2</a:t>
+            </a:r>
+            <a:r>
+              <a:rPr sz="1900">
+                <a:latin typeface="Cambria"/>
+              </a:rPr>
+              <a:t> / (2σ</a:t>
+            </a:r>
+            <a:r>
+              <a:rPr sz="1900" baseline="30000">
+                <a:latin typeface="Cambria"/>
+              </a:rPr>
+              <a:t>2</a:t>
+            </a:r>
+            <a:r>
+              <a:rPr sz="1900">
+                <a:latin typeface="Cambria"/>
+              </a:rPr>
+              <a:t>) )</a:t>
+            </a:r>
+          </a:p>
+        </p:txBody>
+      </p:sp>
+      <p:sp>
+        <p:nvSpPr>
+          <p:cNvPr id="316426" name="TextBox 316425"/>
+          <p:cNvSpPr txBox="1"/>
+          <p:nvPr/>
+        </p:nvSpPr>
+        <p:spPr>
+          <a:xfrm>
+            <a:off x="3965575" y="3954463"/>
+            <a:ext cx="7174523" cy="741362"/>
+          </a:xfrm>
+          <a:prstGeom prst="rect">
+            <a:avLst/>
+          </a:prstGeom>
+          <a:noFill/>
+        </p:spPr>
+        <p:txBody>
+          <a:bodyPr wrap="square" anchor="ctr" lIns="0" rIns="0" tIns="0" bIns="0">
+            <a:spAutoFit/>
+          </a:bodyPr>
+          <a:lstStyle/>
+          <a:p>
+            <a:r>
+              <a:rPr sz="1900">
+                <a:latin typeface="Cambria"/>
+              </a:rPr>
+              <a:t>L = ∏</a:t>
+            </a:r>
+            <a:r>
+              <a:rPr sz="1900" baseline="-25000">
+                <a:latin typeface="Cambria"/>
+              </a:rPr>
+              <a:t>a</a:t>
+            </a:r>
+            <a:r>
+              <a:rPr sz="1900">
+                <a:latin typeface="Cambria"/>
+              </a:rPr>
+              <a:t> 1 / (√(2π) σ) · exp( −(L(a) − L</a:t>
+            </a:r>
+            <a:r>
+              <a:rPr sz="1900" baseline="-25000">
+                <a:latin typeface="Cambria"/>
+              </a:rPr>
+              <a:t>a</a:t>
+            </a:r>
+            <a:r>
+              <a:rPr sz="1900">
+                <a:latin typeface="Cambria"/>
+              </a:rPr>
+              <a:t>)</a:t>
+            </a:r>
+            <a:r>
+              <a:rPr sz="1900" baseline="30000">
+                <a:latin typeface="Cambria"/>
+              </a:rPr>
+              <a:t>2</a:t>
+            </a:r>
+            <a:r>
+              <a:rPr sz="1900">
+                <a:latin typeface="Cambria"/>
+              </a:rPr>
+              <a:t> / (2σ</a:t>
+            </a:r>
+            <a:r>
+              <a:rPr sz="1900" baseline="30000">
+                <a:latin typeface="Cambria"/>
+              </a:rPr>
+              <a:t>2</a:t>
+            </a:r>
+            <a:r>
+              <a:rPr sz="1900">
+                <a:latin typeface="Cambria"/>
+              </a:rPr>
+              <a:t>) )</a:t>
+            </a:r>
           </a:p>
         </p:txBody>
       </p:sp>

</xml_diff>